<commit_message>
Fix process flow: Oportunidad is WIP intermediate, not the origin
The commercial cycle starts in PDB (Activo + Oferta + Demanda + Match)
and only crosses to Dynamics on the Oportunidad handoff. Demand matches
against Offers (not against Assets directly). Updates slides 1, 3, 5,
6, 7 in both FLUJOS_PDB.md and the PPT generator.

Co-Authored-By: Claude Opus 4.7 (1M context) <noreply@anthropic.com>
</commit_message>
<xml_diff>
--- a/FLUJOS_PDB.pptx
+++ b/FLUJOS_PDB.pptx
@@ -2015,7 +2015,7 @@
                 <a:ea typeface="Calibri" pitchFamily="34" charset="-122"/>
                 <a:cs typeface="Calibri" pitchFamily="34" charset="-120"/>
               </a:rPr>
-              <a:t>Cuenta · Oportunidad · Demanda · Activo · Visita · Oferta · Negociación · Instrucción · Transacción</a:t>
+              <a:t>Activo · Oferta · Demanda · Match · Oportunidad WIP · Negociación · Instrucción · Transacción</a:t>
             </a:r>
             <a:endParaRPr lang="en-US" sz="1200" dirty="0"/>
           </a:p>
@@ -7010,7 +7010,7 @@
                 <a:ea typeface="Calibri" pitchFamily="34" charset="-122"/>
                 <a:cs typeface="Calibri" pitchFamily="34" charset="-120"/>
               </a:rPr>
-              <a:t>Cuenta → Oportunidad → Demanda → Activo → Visita → Oferta → Negociación → Instrucción → Transacción</a:t>
+              <a:t>Activo → Oferta + Demanda → Match → Oportunidad WIP → Negociación → Instrucción → Transacción</a:t>
             </a:r>
             <a:endParaRPr lang="en-US" sz="1000" dirty="0"/>
           </a:p>
@@ -7288,8 +7288,8 @@
         </p:nvSpPr>
         <p:spPr>
           <a:xfrm>
-            <a:off x="548640" y="1325880"/>
-            <a:ext cx="1737360" cy="1097280"/>
+            <a:off x="457200" y="1325880"/>
+            <a:ext cx="1691640" cy="1097280"/>
           </a:xfrm>
           <a:prstGeom prst="roundRect">
             <a:avLst>
@@ -7322,8 +7322,8 @@
         </p:nvSpPr>
         <p:spPr>
           <a:xfrm>
-            <a:off x="548640" y="1325880"/>
-            <a:ext cx="1737360" cy="1097280"/>
+            <a:off x="457200" y="1325880"/>
+            <a:ext cx="1691640" cy="1097280"/>
           </a:xfrm>
           <a:prstGeom prst="rect">
             <a:avLst/>
@@ -7347,7 +7347,7 @@
                 <a:ea typeface="Calibri" pitchFamily="34" charset="-122"/>
                 <a:cs typeface="Calibri" pitchFamily="34" charset="-120"/>
               </a:rPr>
-              <a:t>Cuenta</a:t>
+              <a:t>Cuenta-</a:t>
             </a:r>
             <a:endParaRPr lang="en-US" sz="1000" dirty="0"/>
           </a:p>
@@ -7364,7 +7364,7 @@
                 <a:ea typeface="Calibri" pitchFamily="34" charset="-122"/>
                 <a:cs typeface="Calibri" pitchFamily="34" charset="-120"/>
               </a:rPr>
-              <a:t>Alta fuente</a:t>
+              <a:t>Propietario</a:t>
             </a:r>
             <a:endParaRPr lang="en-US" sz="1000" dirty="0"/>
           </a:p>
@@ -7381,7 +7381,24 @@
                 <a:ea typeface="Calibri" pitchFamily="34" charset="-122"/>
                 <a:cs typeface="Calibri" pitchFamily="34" charset="-120"/>
               </a:rPr>
-              <a:t>de verdad</a:t>
+              <a:t>fuente de</a:t>
+            </a:r>
+            <a:endParaRPr lang="en-US" sz="1000" dirty="0"/>
+          </a:p>
+          <a:p>
+            <a:pPr algn="ctr" indent="0" marL="0">
+              <a:buNone/>
+            </a:pPr>
+            <a:r>
+              <a:rPr lang="en-US" sz="1000" dirty="0">
+                <a:solidFill>
+                  <a:srgbClr val="FFFFFF"/>
+                </a:solidFill>
+                <a:latin typeface="Calibri" pitchFamily="34" charset="0"/>
+                <a:ea typeface="Calibri" pitchFamily="34" charset="-122"/>
+                <a:cs typeface="Calibri" pitchFamily="34" charset="-120"/>
+              </a:rPr>
+              <a:t>verdad</a:t>
             </a:r>
             <a:endParaRPr lang="en-US" sz="1000" dirty="0"/>
           </a:p>
@@ -7395,7 +7412,7 @@
         </p:nvSpPr>
         <p:spPr>
           <a:xfrm>
-            <a:off x="438912" y="1216152"/>
+            <a:off x="347472" y="1216152"/>
             <a:ext cx="329184" cy="329184"/>
           </a:xfrm>
           <a:prstGeom prst="ellipse">
@@ -7420,7 +7437,7 @@
         </p:nvSpPr>
         <p:spPr>
           <a:xfrm>
-            <a:off x="438912" y="1216152"/>
+            <a:off x="347472" y="1216152"/>
             <a:ext cx="329184" cy="329184"/>
           </a:xfrm>
           <a:prstGeom prst="rect">
@@ -7459,8 +7476,8 @@
         </p:nvSpPr>
         <p:spPr>
           <a:xfrm>
-            <a:off x="2606040" y="1325880"/>
-            <a:ext cx="1737360" cy="1097280"/>
+            <a:off x="4160520" y="1325880"/>
+            <a:ext cx="1691640" cy="1097280"/>
           </a:xfrm>
           <a:prstGeom prst="roundRect">
             <a:avLst>
@@ -7493,8 +7510,8 @@
         </p:nvSpPr>
         <p:spPr>
           <a:xfrm>
-            <a:off x="2606040" y="1325880"/>
-            <a:ext cx="1737360" cy="1097280"/>
+            <a:off x="4160520" y="1325880"/>
+            <a:ext cx="1691640" cy="1097280"/>
           </a:xfrm>
           <a:prstGeom prst="rect">
             <a:avLst/>
@@ -7518,7 +7535,7 @@
                 <a:ea typeface="Calibri" pitchFamily="34" charset="-122"/>
                 <a:cs typeface="Calibri" pitchFamily="34" charset="-120"/>
               </a:rPr>
-              <a:t>Oportunidad</a:t>
+              <a:t>Cuenta-</a:t>
             </a:r>
             <a:endParaRPr lang="en-US" sz="1000" dirty="0"/>
           </a:p>
@@ -7535,7 +7552,7 @@
                 <a:ea typeface="Calibri" pitchFamily="34" charset="-122"/>
                 <a:cs typeface="Calibri" pitchFamily="34" charset="-120"/>
               </a:rPr>
-              <a:t>Detección</a:t>
+              <a:t>Arrendatario</a:t>
             </a:r>
             <a:endParaRPr lang="en-US" sz="1000" dirty="0"/>
           </a:p>
@@ -7552,7 +7569,24 @@
                 <a:ea typeface="Calibri" pitchFamily="34" charset="-122"/>
                 <a:cs typeface="Calibri" pitchFamily="34" charset="-120"/>
               </a:rPr>
-              <a:t>comercial</a:t>
+              <a:t>fuente de</a:t>
+            </a:r>
+            <a:endParaRPr lang="en-US" sz="1000" dirty="0"/>
+          </a:p>
+          <a:p>
+            <a:pPr algn="ctr" indent="0" marL="0">
+              <a:buNone/>
+            </a:pPr>
+            <a:r>
+              <a:rPr lang="en-US" sz="1000" dirty="0">
+                <a:solidFill>
+                  <a:srgbClr val="FFFFFF"/>
+                </a:solidFill>
+                <a:latin typeface="Calibri" pitchFamily="34" charset="0"/>
+                <a:ea typeface="Calibri" pitchFamily="34" charset="-122"/>
+                <a:cs typeface="Calibri" pitchFamily="34" charset="-120"/>
+              </a:rPr>
+              <a:t>verdad</a:t>
             </a:r>
             <a:endParaRPr lang="en-US" sz="1000" dirty="0"/>
           </a:p>
@@ -7566,7 +7600,7 @@
         </p:nvSpPr>
         <p:spPr>
           <a:xfrm>
-            <a:off x="2496312" y="1216152"/>
+            <a:off x="4050792" y="1216152"/>
             <a:ext cx="329184" cy="329184"/>
           </a:xfrm>
           <a:prstGeom prst="ellipse">
@@ -7591,7 +7625,7 @@
         </p:nvSpPr>
         <p:spPr>
           <a:xfrm>
-            <a:off x="2496312" y="1216152"/>
+            <a:off x="4050792" y="1216152"/>
             <a:ext cx="329184" cy="329184"/>
           </a:xfrm>
           <a:prstGeom prst="rect">
@@ -7616,7 +7650,7 @@
                 <a:ea typeface="Calibri" pitchFamily="34" charset="-122"/>
                 <a:cs typeface="Calibri" pitchFamily="34" charset="-120"/>
               </a:rPr>
-              <a:t>2</a:t>
+              <a:t>4</a:t>
             </a:r>
             <a:endParaRPr lang="en-US" sz="1000" dirty="0"/>
           </a:p>
@@ -7630,8 +7664,8 @@
         </p:nvSpPr>
         <p:spPr>
           <a:xfrm>
-            <a:off x="8686800" y="1325880"/>
-            <a:ext cx="1737360" cy="1097280"/>
+            <a:off x="7269480" y="1325880"/>
+            <a:ext cx="1691640" cy="1097280"/>
           </a:xfrm>
           <a:prstGeom prst="roundRect">
             <a:avLst>
@@ -7664,8 +7698,8 @@
         </p:nvSpPr>
         <p:spPr>
           <a:xfrm>
-            <a:off x="8686800" y="1325880"/>
-            <a:ext cx="1737360" cy="1097280"/>
+            <a:off x="7269480" y="1325880"/>
+            <a:ext cx="1691640" cy="1097280"/>
           </a:xfrm>
           <a:prstGeom prst="rect">
             <a:avLst/>
@@ -7681,51 +7715,68 @@
               <a:buNone/>
             </a:pPr>
             <a:r>
-              <a:rPr lang="en-US" sz="1000" dirty="0">
-                <a:solidFill>
-                  <a:srgbClr val="FFFFFF"/>
-                </a:solidFill>
-                <a:latin typeface="Calibri" pitchFamily="34" charset="0"/>
-                <a:ea typeface="Calibri" pitchFamily="34" charset="-122"/>
-                <a:cs typeface="Calibri" pitchFamily="34" charset="-120"/>
-              </a:rPr>
-              <a:t>Instrucción</a:t>
-            </a:r>
-            <a:endParaRPr lang="en-US" sz="1000" dirty="0"/>
-          </a:p>
-          <a:p>
-            <a:pPr algn="ctr" indent="0" marL="0">
-              <a:buNone/>
-            </a:pPr>
-            <a:r>
-              <a:rPr lang="en-US" sz="1000" dirty="0">
-                <a:solidFill>
-                  <a:srgbClr val="FFFFFF"/>
-                </a:solidFill>
-                <a:latin typeface="Calibri" pitchFamily="34" charset="0"/>
-                <a:ea typeface="Calibri" pitchFamily="34" charset="-122"/>
-                <a:cs typeface="Calibri" pitchFamily="34" charset="-120"/>
-              </a:rPr>
-              <a:t>Mandato</a:t>
-            </a:r>
-            <a:endParaRPr lang="en-US" sz="1000" dirty="0"/>
-          </a:p>
-          <a:p>
-            <a:pPr algn="ctr" indent="0" marL="0">
-              <a:buNone/>
-            </a:pPr>
-            <a:r>
-              <a:rPr lang="en-US" sz="1000" dirty="0">
-                <a:solidFill>
-                  <a:srgbClr val="FFFFFF"/>
-                </a:solidFill>
-                <a:latin typeface="Calibri" pitchFamily="34" charset="0"/>
-                <a:ea typeface="Calibri" pitchFamily="34" charset="-122"/>
-                <a:cs typeface="Calibri" pitchFamily="34" charset="-120"/>
-              </a:rPr>
-              <a:t>formal</a:t>
-            </a:r>
-            <a:endParaRPr lang="en-US" sz="1000" dirty="0"/>
+              <a:rPr lang="en-US" sz="900" dirty="0">
+                <a:solidFill>
+                  <a:srgbClr val="FFFFFF"/>
+                </a:solidFill>
+                <a:latin typeface="Calibri" pitchFamily="34" charset="0"/>
+                <a:ea typeface="Calibri" pitchFamily="34" charset="-122"/>
+                <a:cs typeface="Calibri" pitchFamily="34" charset="-120"/>
+              </a:rPr>
+              <a:t>Oportunidad</a:t>
+            </a:r>
+            <a:endParaRPr lang="en-US" sz="900" dirty="0"/>
+          </a:p>
+          <a:p>
+            <a:pPr algn="ctr" indent="0" marL="0">
+              <a:buNone/>
+            </a:pPr>
+            <a:r>
+              <a:rPr lang="en-US" sz="900" dirty="0">
+                <a:solidFill>
+                  <a:srgbClr val="FFFFFF"/>
+                </a:solidFill>
+                <a:latin typeface="Calibri" pitchFamily="34" charset="0"/>
+                <a:ea typeface="Calibri" pitchFamily="34" charset="-122"/>
+                <a:cs typeface="Calibri" pitchFamily="34" charset="-120"/>
+              </a:rPr>
+              <a:t>WIP</a:t>
+            </a:r>
+            <a:endParaRPr lang="en-US" sz="900" dirty="0"/>
+          </a:p>
+          <a:p>
+            <a:pPr algn="ctr" indent="0" marL="0">
+              <a:buNone/>
+            </a:pPr>
+            <a:r>
+              <a:rPr lang="en-US" sz="900" dirty="0">
+                <a:solidFill>
+                  <a:srgbClr val="FFFFFF"/>
+                </a:solidFill>
+                <a:latin typeface="Calibri" pitchFamily="34" charset="0"/>
+                <a:ea typeface="Calibri" pitchFamily="34" charset="-122"/>
+                <a:cs typeface="Calibri" pitchFamily="34" charset="-120"/>
+              </a:rPr>
+              <a:t>handoff #1</a:t>
+            </a:r>
+            <a:endParaRPr lang="en-US" sz="900" dirty="0"/>
+          </a:p>
+          <a:p>
+            <a:pPr algn="ctr" indent="0" marL="0">
+              <a:buNone/>
+            </a:pPr>
+            <a:r>
+              <a:rPr lang="en-US" sz="900" dirty="0">
+                <a:solidFill>
+                  <a:srgbClr val="FFFFFF"/>
+                </a:solidFill>
+                <a:latin typeface="Calibri" pitchFamily="34" charset="0"/>
+                <a:ea typeface="Calibri" pitchFamily="34" charset="-122"/>
+                <a:cs typeface="Calibri" pitchFamily="34" charset="-120"/>
+              </a:rPr>
+              <a:t>registro maestro</a:t>
+            </a:r>
+            <a:endParaRPr lang="en-US" sz="900" dirty="0"/>
           </a:p>
         </p:txBody>
       </p:sp>
@@ -7737,7 +7788,7 @@
         </p:nvSpPr>
         <p:spPr>
           <a:xfrm>
-            <a:off x="8577072" y="1216152"/>
+            <a:off x="7159752" y="1216152"/>
             <a:ext cx="329184" cy="329184"/>
           </a:xfrm>
           <a:prstGeom prst="ellipse">
@@ -7762,7 +7813,7 @@
         </p:nvSpPr>
         <p:spPr>
           <a:xfrm>
-            <a:off x="8577072" y="1216152"/>
+            <a:off x="7159752" y="1216152"/>
             <a:ext cx="329184" cy="329184"/>
           </a:xfrm>
           <a:prstGeom prst="rect">
@@ -7787,7 +7838,7 @@
                 <a:ea typeface="Calibri" pitchFamily="34" charset="-122"/>
                 <a:cs typeface="Calibri" pitchFamily="34" charset="-120"/>
               </a:rPr>
-              <a:t>8</a:t>
+              <a:t>7</a:t>
             </a:r>
             <a:endParaRPr lang="en-US" sz="1000" dirty="0"/>
           </a:p>
@@ -7801,8 +7852,8 @@
         </p:nvSpPr>
         <p:spPr>
           <a:xfrm>
-            <a:off x="548640" y="3611880"/>
-            <a:ext cx="1554480" cy="1097280"/>
+            <a:off x="10104120" y="1325880"/>
+            <a:ext cx="1691640" cy="1097280"/>
           </a:xfrm>
           <a:prstGeom prst="roundRect">
             <a:avLst>
@@ -7810,11 +7861,11 @@
             </a:avLst>
           </a:prstGeom>
           <a:solidFill>
-            <a:srgbClr val="2E7D32"/>
+            <a:srgbClr val="0078D4"/>
           </a:solidFill>
           <a:ln w="19050">
             <a:solidFill>
-              <a:srgbClr val="1B5E20"/>
+              <a:srgbClr val="005A9E"/>
             </a:solidFill>
             <a:prstDash val="solid"/>
           </a:ln>
@@ -7835,8 +7886,8 @@
         </p:nvSpPr>
         <p:spPr>
           <a:xfrm>
-            <a:off x="548640" y="3611880"/>
-            <a:ext cx="1554480" cy="1097280"/>
+            <a:off x="10104120" y="1325880"/>
+            <a:ext cx="1691640" cy="1097280"/>
           </a:xfrm>
           <a:prstGeom prst="rect">
             <a:avLst/>
@@ -7860,7 +7911,7 @@
                 <a:ea typeface="Calibri" pitchFamily="34" charset="-122"/>
                 <a:cs typeface="Calibri" pitchFamily="34" charset="-120"/>
               </a:rPr>
-              <a:t>Demanda</a:t>
+              <a:t>Instrucción</a:t>
             </a:r>
             <a:endParaRPr lang="en-US" sz="1000" dirty="0"/>
           </a:p>
@@ -7877,7 +7928,7 @@
                 <a:ea typeface="Calibri" pitchFamily="34" charset="-122"/>
                 <a:cs typeface="Calibri" pitchFamily="34" charset="-120"/>
               </a:rPr>
-              <a:t>Cualificación</a:t>
+              <a:t>handoff #2</a:t>
             </a:r>
             <a:endParaRPr lang="en-US" sz="1000" dirty="0"/>
           </a:p>
@@ -7894,7 +7945,7 @@
                 <a:ea typeface="Calibri" pitchFamily="34" charset="-122"/>
                 <a:cs typeface="Calibri" pitchFamily="34" charset="-120"/>
               </a:rPr>
-              <a:t>necesidad</a:t>
+              <a:t>contrato</a:t>
             </a:r>
             <a:endParaRPr lang="en-US" sz="1000" dirty="0"/>
           </a:p>
@@ -7908,7 +7959,7 @@
         </p:nvSpPr>
         <p:spPr>
           <a:xfrm>
-            <a:off x="438912" y="3502152"/>
+            <a:off x="9994392" y="1216152"/>
             <a:ext cx="329184" cy="329184"/>
           </a:xfrm>
           <a:prstGeom prst="ellipse">
@@ -7933,7 +7984,7 @@
         </p:nvSpPr>
         <p:spPr>
           <a:xfrm>
-            <a:off x="438912" y="3502152"/>
+            <a:off x="9994392" y="1216152"/>
             <a:ext cx="329184" cy="329184"/>
           </a:xfrm>
           <a:prstGeom prst="rect">
@@ -7958,7 +8009,7 @@
                 <a:ea typeface="Calibri" pitchFamily="34" charset="-122"/>
                 <a:cs typeface="Calibri" pitchFamily="34" charset="-120"/>
               </a:rPr>
-              <a:t>3</a:t>
+              <a:t>9</a:t>
             </a:r>
             <a:endParaRPr lang="en-US" sz="1000" dirty="0"/>
           </a:p>
@@ -7972,8 +8023,8 @@
         </p:nvSpPr>
         <p:spPr>
           <a:xfrm>
-            <a:off x="2331720" y="3611880"/>
-            <a:ext cx="1554480" cy="1097280"/>
+            <a:off x="457200" y="3611880"/>
+            <a:ext cx="1691640" cy="1097280"/>
           </a:xfrm>
           <a:prstGeom prst="roundRect">
             <a:avLst>
@@ -8006,145 +8057,145 @@
         </p:nvSpPr>
         <p:spPr>
           <a:xfrm>
+            <a:off x="457200" y="3611880"/>
+            <a:ext cx="1691640" cy="1097280"/>
+          </a:xfrm>
+          <a:prstGeom prst="rect">
+            <a:avLst/>
+          </a:prstGeom>
+          <a:noFill/>
+          <a:ln/>
+        </p:spPr>
+        <p:txBody>
+          <a:bodyPr wrap="square" rtlCol="0" anchor="ctr"/>
+          <a:lstStyle/>
+          <a:p>
+            <a:pPr algn="ctr" indent="0" marL="0">
+              <a:buNone/>
+            </a:pPr>
+            <a:r>
+              <a:rPr lang="en-US" sz="1000" dirty="0">
+                <a:solidFill>
+                  <a:srgbClr val="FFFFFF"/>
+                </a:solidFill>
+                <a:latin typeface="Calibri" pitchFamily="34" charset="0"/>
+                <a:ea typeface="Calibri" pitchFamily="34" charset="-122"/>
+                <a:cs typeface="Calibri" pitchFamily="34" charset="-120"/>
+              </a:rPr>
+              <a:t>Activo</a:t>
+            </a:r>
+            <a:endParaRPr lang="en-US" sz="1000" dirty="0"/>
+          </a:p>
+          <a:p>
+            <a:pPr algn="ctr" indent="0" marL="0">
+              <a:buNone/>
+            </a:pPr>
+            <a:r>
+              <a:rPr lang="en-US" sz="1000" dirty="0">
+                <a:solidFill>
+                  <a:srgbClr val="FFFFFF"/>
+                </a:solidFill>
+                <a:latin typeface="Calibri" pitchFamily="34" charset="0"/>
+                <a:ea typeface="Calibri" pitchFamily="34" charset="-122"/>
+                <a:cs typeface="Calibri" pitchFamily="34" charset="-120"/>
+              </a:rPr>
+              <a:t>alta +</a:t>
+            </a:r>
+            <a:endParaRPr lang="en-US" sz="1000" dirty="0"/>
+          </a:p>
+          <a:p>
+            <a:pPr algn="ctr" indent="0" marL="0">
+              <a:buNone/>
+            </a:pPr>
+            <a:r>
+              <a:rPr lang="en-US" sz="1000" dirty="0">
+                <a:solidFill>
+                  <a:srgbClr val="FFFFFF"/>
+                </a:solidFill>
+                <a:latin typeface="Calibri" pitchFamily="34" charset="0"/>
+                <a:ea typeface="Calibri" pitchFamily="34" charset="-122"/>
+                <a:cs typeface="Calibri" pitchFamily="34" charset="-120"/>
+              </a:rPr>
+              <a:t>publicación</a:t>
+            </a:r>
+            <a:endParaRPr lang="en-US" sz="1000" dirty="0"/>
+          </a:p>
+        </p:txBody>
+      </p:sp>
+      <p:sp>
+        <p:nvSpPr>
+          <p:cNvPr id="33" name="Shape 31"/>
+          <p:cNvSpPr/>
+          <p:nvPr/>
+        </p:nvSpPr>
+        <p:spPr>
+          <a:xfrm>
+            <a:off x="347472" y="3502152"/>
+            <a:ext cx="329184" cy="329184"/>
+          </a:xfrm>
+          <a:prstGeom prst="ellipse">
+            <a:avLst/>
+          </a:prstGeom>
+          <a:solidFill>
+            <a:srgbClr val="1A237E"/>
+          </a:solidFill>
+          <a:ln w="25400">
+            <a:solidFill>
+              <a:srgbClr val="FFFFFF"/>
+            </a:solidFill>
+            <a:prstDash val="solid"/>
+          </a:ln>
+        </p:spPr>
+      </p:sp>
+      <p:sp>
+        <p:nvSpPr>
+          <p:cNvPr id="34" name="Text 32"/>
+          <p:cNvSpPr/>
+          <p:nvPr/>
+        </p:nvSpPr>
+        <p:spPr>
+          <a:xfrm>
+            <a:off x="347472" y="3502152"/>
+            <a:ext cx="329184" cy="329184"/>
+          </a:xfrm>
+          <a:prstGeom prst="rect">
+            <a:avLst/>
+          </a:prstGeom>
+          <a:noFill/>
+          <a:ln/>
+        </p:spPr>
+        <p:txBody>
+          <a:bodyPr wrap="square" rtlCol="0" anchor="ctr"/>
+          <a:lstStyle/>
+          <a:p>
+            <a:pPr algn="ctr" indent="0" marL="0">
+              <a:buNone/>
+            </a:pPr>
+            <a:r>
+              <a:rPr lang="en-US" sz="1000" b="1" dirty="0">
+                <a:solidFill>
+                  <a:srgbClr val="FFFFFF"/>
+                </a:solidFill>
+                <a:latin typeface="Calibri" pitchFamily="34" charset="0"/>
+                <a:ea typeface="Calibri" pitchFamily="34" charset="-122"/>
+                <a:cs typeface="Calibri" pitchFamily="34" charset="-120"/>
+              </a:rPr>
+              <a:t>2</a:t>
+            </a:r>
+            <a:endParaRPr lang="en-US" sz="1000" dirty="0"/>
+          </a:p>
+        </p:txBody>
+      </p:sp>
+      <p:sp>
+        <p:nvSpPr>
+          <p:cNvPr id="35" name="Shape 33"/>
+          <p:cNvSpPr/>
+          <p:nvPr/>
+        </p:nvSpPr>
+        <p:spPr>
+          <a:xfrm>
             <a:off x="2331720" y="3611880"/>
-            <a:ext cx="1554480" cy="1097280"/>
-          </a:xfrm>
-          <a:prstGeom prst="rect">
-            <a:avLst/>
-          </a:prstGeom>
-          <a:noFill/>
-          <a:ln/>
-        </p:spPr>
-        <p:txBody>
-          <a:bodyPr wrap="square" rtlCol="0" anchor="ctr"/>
-          <a:lstStyle/>
-          <a:p>
-            <a:pPr algn="ctr" indent="0" marL="0">
-              <a:buNone/>
-            </a:pPr>
-            <a:r>
-              <a:rPr lang="en-US" sz="1000" dirty="0">
-                <a:solidFill>
-                  <a:srgbClr val="FFFFFF"/>
-                </a:solidFill>
-                <a:latin typeface="Calibri" pitchFamily="34" charset="0"/>
-                <a:ea typeface="Calibri" pitchFamily="34" charset="-122"/>
-                <a:cs typeface="Calibri" pitchFamily="34" charset="-120"/>
-              </a:rPr>
-              <a:t>Activo</a:t>
-            </a:r>
-            <a:endParaRPr lang="en-US" sz="1000" dirty="0"/>
-          </a:p>
-          <a:p>
-            <a:pPr algn="ctr" indent="0" marL="0">
-              <a:buNone/>
-            </a:pPr>
-            <a:r>
-              <a:rPr lang="en-US" sz="1000" dirty="0">
-                <a:solidFill>
-                  <a:srgbClr val="FFFFFF"/>
-                </a:solidFill>
-                <a:latin typeface="Calibri" pitchFamily="34" charset="0"/>
-                <a:ea typeface="Calibri" pitchFamily="34" charset="-122"/>
-                <a:cs typeface="Calibri" pitchFamily="34" charset="-120"/>
-              </a:rPr>
-              <a:t>Producto</a:t>
-            </a:r>
-            <a:endParaRPr lang="en-US" sz="1000" dirty="0"/>
-          </a:p>
-          <a:p>
-            <a:pPr algn="ctr" indent="0" marL="0">
-              <a:buNone/>
-            </a:pPr>
-            <a:r>
-              <a:rPr lang="en-US" sz="1000" dirty="0">
-                <a:solidFill>
-                  <a:srgbClr val="FFFFFF"/>
-                </a:solidFill>
-                <a:latin typeface="Calibri" pitchFamily="34" charset="0"/>
-                <a:ea typeface="Calibri" pitchFamily="34" charset="-122"/>
-                <a:cs typeface="Calibri" pitchFamily="34" charset="-120"/>
-              </a:rPr>
-              <a:t>disponible</a:t>
-            </a:r>
-            <a:endParaRPr lang="en-US" sz="1000" dirty="0"/>
-          </a:p>
-        </p:txBody>
-      </p:sp>
-      <p:sp>
-        <p:nvSpPr>
-          <p:cNvPr id="33" name="Shape 31"/>
-          <p:cNvSpPr/>
-          <p:nvPr/>
-        </p:nvSpPr>
-        <p:spPr>
-          <a:xfrm>
-            <a:off x="2221992" y="3502152"/>
-            <a:ext cx="329184" cy="329184"/>
-          </a:xfrm>
-          <a:prstGeom prst="ellipse">
-            <a:avLst/>
-          </a:prstGeom>
-          <a:solidFill>
-            <a:srgbClr val="1A237E"/>
-          </a:solidFill>
-          <a:ln w="25400">
-            <a:solidFill>
-              <a:srgbClr val="FFFFFF"/>
-            </a:solidFill>
-            <a:prstDash val="solid"/>
-          </a:ln>
-        </p:spPr>
-      </p:sp>
-      <p:sp>
-        <p:nvSpPr>
-          <p:cNvPr id="34" name="Text 32"/>
-          <p:cNvSpPr/>
-          <p:nvPr/>
-        </p:nvSpPr>
-        <p:spPr>
-          <a:xfrm>
-            <a:off x="2221992" y="3502152"/>
-            <a:ext cx="329184" cy="329184"/>
-          </a:xfrm>
-          <a:prstGeom prst="rect">
-            <a:avLst/>
-          </a:prstGeom>
-          <a:noFill/>
-          <a:ln/>
-        </p:spPr>
-        <p:txBody>
-          <a:bodyPr wrap="square" rtlCol="0" anchor="ctr"/>
-          <a:lstStyle/>
-          <a:p>
-            <a:pPr algn="ctr" indent="0" marL="0">
-              <a:buNone/>
-            </a:pPr>
-            <a:r>
-              <a:rPr lang="en-US" sz="1000" b="1" dirty="0">
-                <a:solidFill>
-                  <a:srgbClr val="FFFFFF"/>
-                </a:solidFill>
-                <a:latin typeface="Calibri" pitchFamily="34" charset="0"/>
-                <a:ea typeface="Calibri" pitchFamily="34" charset="-122"/>
-                <a:cs typeface="Calibri" pitchFamily="34" charset="-120"/>
-              </a:rPr>
-              <a:t>4</a:t>
-            </a:r>
-            <a:endParaRPr lang="en-US" sz="1000" dirty="0"/>
-          </a:p>
-        </p:txBody>
-      </p:sp>
-      <p:sp>
-        <p:nvSpPr>
-          <p:cNvPr id="35" name="Shape 33"/>
-          <p:cNvSpPr/>
-          <p:nvPr/>
-        </p:nvSpPr>
-        <p:spPr>
-          <a:xfrm>
-            <a:off x="4114800" y="3611880"/>
-            <a:ext cx="1554480" cy="1097280"/>
+            <a:ext cx="1691640" cy="1097280"/>
           </a:xfrm>
           <a:prstGeom prst="roundRect">
             <a:avLst>
@@ -8177,8 +8228,8 @@
         </p:nvSpPr>
         <p:spPr>
           <a:xfrm>
-            <a:off x="4114800" y="3611880"/>
-            <a:ext cx="1554480" cy="1097280"/>
+            <a:off x="2331720" y="3611880"/>
+            <a:ext cx="1691640" cy="1097280"/>
           </a:xfrm>
           <a:prstGeom prst="rect">
             <a:avLst/>
@@ -8202,7 +8253,7 @@
                 <a:ea typeface="Calibri" pitchFamily="34" charset="-122"/>
                 <a:cs typeface="Calibri" pitchFamily="34" charset="-120"/>
               </a:rPr>
-              <a:t>Visita</a:t>
+              <a:t>Oferta</a:t>
             </a:r>
             <a:endParaRPr lang="en-US" sz="1000" dirty="0"/>
           </a:p>
@@ -8219,7 +8270,7 @@
                 <a:ea typeface="Calibri" pitchFamily="34" charset="-122"/>
                 <a:cs typeface="Calibri" pitchFamily="34" charset="-120"/>
               </a:rPr>
-              <a:t>Inspección</a:t>
+              <a:t>producto</a:t>
             </a:r>
             <a:endParaRPr lang="en-US" sz="1000" dirty="0"/>
           </a:p>
@@ -8236,7 +8287,7 @@
                 <a:ea typeface="Calibri" pitchFamily="34" charset="-122"/>
                 <a:cs typeface="Calibri" pitchFamily="34" charset="-120"/>
               </a:rPr>
-              <a:t>física</a:t>
+              <a:t>al mercado</a:t>
             </a:r>
             <a:endParaRPr lang="en-US" sz="1000" dirty="0"/>
           </a:p>
@@ -8250,7 +8301,7 @@
         </p:nvSpPr>
         <p:spPr>
           <a:xfrm>
-            <a:off x="4005072" y="3502152"/>
+            <a:off x="2221992" y="3502152"/>
             <a:ext cx="329184" cy="329184"/>
           </a:xfrm>
           <a:prstGeom prst="ellipse">
@@ -8275,7 +8326,7 @@
         </p:nvSpPr>
         <p:spPr>
           <a:xfrm>
-            <a:off x="4005072" y="3502152"/>
+            <a:off x="2221992" y="3502152"/>
             <a:ext cx="329184" cy="329184"/>
           </a:xfrm>
           <a:prstGeom prst="rect">
@@ -8300,7 +8351,7 @@
                 <a:ea typeface="Calibri" pitchFamily="34" charset="-122"/>
                 <a:cs typeface="Calibri" pitchFamily="34" charset="-120"/>
               </a:rPr>
-              <a:t>5</a:t>
+              <a:t>3</a:t>
             </a:r>
             <a:endParaRPr lang="en-US" sz="1000" dirty="0"/>
           </a:p>
@@ -8314,8 +8365,8 @@
         </p:nvSpPr>
         <p:spPr>
           <a:xfrm>
-            <a:off x="5897880" y="3611880"/>
-            <a:ext cx="1554480" cy="1097280"/>
+            <a:off x="4160520" y="3611880"/>
+            <a:ext cx="1691640" cy="1097280"/>
           </a:xfrm>
           <a:prstGeom prst="roundRect">
             <a:avLst>
@@ -8348,8 +8399,8 @@
         </p:nvSpPr>
         <p:spPr>
           <a:xfrm>
-            <a:off x="5897880" y="3611880"/>
-            <a:ext cx="1554480" cy="1097280"/>
+            <a:off x="4160520" y="3611880"/>
+            <a:ext cx="1691640" cy="1097280"/>
           </a:xfrm>
           <a:prstGeom prst="rect">
             <a:avLst/>
@@ -8373,7 +8424,7 @@
                 <a:ea typeface="Calibri" pitchFamily="34" charset="-122"/>
                 <a:cs typeface="Calibri" pitchFamily="34" charset="-120"/>
               </a:rPr>
-              <a:t>Oferta</a:t>
+              <a:t>Demanda</a:t>
             </a:r>
             <a:endParaRPr lang="en-US" sz="1000" dirty="0"/>
           </a:p>
@@ -8390,7 +8441,7 @@
                 <a:ea typeface="Calibri" pitchFamily="34" charset="-122"/>
                 <a:cs typeface="Calibri" pitchFamily="34" charset="-120"/>
               </a:rPr>
-              <a:t>Propuesta</a:t>
+              <a:t>perfil</a:t>
             </a:r>
             <a:endParaRPr lang="en-US" sz="1000" dirty="0"/>
           </a:p>
@@ -8407,7 +8458,7 @@
                 <a:ea typeface="Calibri" pitchFamily="34" charset="-122"/>
                 <a:cs typeface="Calibri" pitchFamily="34" charset="-120"/>
               </a:rPr>
-              <a:t>económica</a:t>
+              <a:t>búsqueda</a:t>
             </a:r>
             <a:endParaRPr lang="en-US" sz="1000" dirty="0"/>
           </a:p>
@@ -8421,7 +8472,7 @@
         </p:nvSpPr>
         <p:spPr>
           <a:xfrm>
-            <a:off x="5788152" y="3502152"/>
+            <a:off x="4050792" y="3502152"/>
             <a:ext cx="329184" cy="329184"/>
           </a:xfrm>
           <a:prstGeom prst="ellipse">
@@ -8446,7 +8497,7 @@
         </p:nvSpPr>
         <p:spPr>
           <a:xfrm>
-            <a:off x="5788152" y="3502152"/>
+            <a:off x="4050792" y="3502152"/>
             <a:ext cx="329184" cy="329184"/>
           </a:xfrm>
           <a:prstGeom prst="rect">
@@ -8471,7 +8522,7 @@
                 <a:ea typeface="Calibri" pitchFamily="34" charset="-122"/>
                 <a:cs typeface="Calibri" pitchFamily="34" charset="-120"/>
               </a:rPr>
-              <a:t>6</a:t>
+              <a:t>5</a:t>
             </a:r>
             <a:endParaRPr lang="en-US" sz="1000" dirty="0"/>
           </a:p>
@@ -8485,8 +8536,8 @@
         </p:nvSpPr>
         <p:spPr>
           <a:xfrm>
-            <a:off x="7680960" y="3611880"/>
-            <a:ext cx="1554480" cy="1097280"/>
+            <a:off x="5989320" y="3611880"/>
+            <a:ext cx="1691640" cy="1097280"/>
           </a:xfrm>
           <a:prstGeom prst="roundRect">
             <a:avLst>
@@ -8519,8 +8570,8 @@
         </p:nvSpPr>
         <p:spPr>
           <a:xfrm>
-            <a:off x="7680960" y="3611880"/>
-            <a:ext cx="1554480" cy="1097280"/>
+            <a:off x="5989320" y="3611880"/>
+            <a:ext cx="1691640" cy="1097280"/>
           </a:xfrm>
           <a:prstGeom prst="rect">
             <a:avLst/>
@@ -8544,7 +8595,7 @@
                 <a:ea typeface="Calibri" pitchFamily="34" charset="-122"/>
                 <a:cs typeface="Calibri" pitchFamily="34" charset="-120"/>
               </a:rPr>
-              <a:t>Negociación</a:t>
+              <a:t>Match</a:t>
             </a:r>
             <a:endParaRPr lang="en-US" sz="1000" dirty="0"/>
           </a:p>
@@ -8561,7 +8612,7 @@
                 <a:ea typeface="Calibri" pitchFamily="34" charset="-122"/>
                 <a:cs typeface="Calibri" pitchFamily="34" charset="-120"/>
               </a:rPr>
-              <a:t>Hilo</a:t>
+              <a:t>Oferta ↔</a:t>
             </a:r>
             <a:endParaRPr lang="en-US" sz="1000" dirty="0"/>
           </a:p>
@@ -8578,7 +8629,7 @@
                 <a:ea typeface="Calibri" pitchFamily="34" charset="-122"/>
                 <a:cs typeface="Calibri" pitchFamily="34" charset="-120"/>
               </a:rPr>
-              <a:t>condiciones</a:t>
+              <a:t>Demanda</a:t>
             </a:r>
             <a:endParaRPr lang="en-US" sz="1000" dirty="0"/>
           </a:p>
@@ -8592,7 +8643,7 @@
         </p:nvSpPr>
         <p:spPr>
           <a:xfrm>
-            <a:off x="7571232" y="3502152"/>
+            <a:off x="5879592" y="3502152"/>
             <a:ext cx="329184" cy="329184"/>
           </a:xfrm>
           <a:prstGeom prst="ellipse">
@@ -8617,7 +8668,7 @@
         </p:nvSpPr>
         <p:spPr>
           <a:xfrm>
-            <a:off x="7571232" y="3502152"/>
+            <a:off x="5879592" y="3502152"/>
             <a:ext cx="329184" cy="329184"/>
           </a:xfrm>
           <a:prstGeom prst="rect">
@@ -8642,7 +8693,7 @@
                 <a:ea typeface="Calibri" pitchFamily="34" charset="-122"/>
                 <a:cs typeface="Calibri" pitchFamily="34" charset="-120"/>
               </a:rPr>
-              <a:t>7</a:t>
+              <a:t>6</a:t>
             </a:r>
             <a:endParaRPr lang="en-US" sz="1000" dirty="0"/>
           </a:p>
@@ -8656,8 +8707,8 @@
         </p:nvSpPr>
         <p:spPr>
           <a:xfrm>
-            <a:off x="10104120" y="3611880"/>
-            <a:ext cx="1737360" cy="1097280"/>
+            <a:off x="8229600" y="3611880"/>
+            <a:ext cx="1691640" cy="1097280"/>
           </a:xfrm>
           <a:prstGeom prst="roundRect">
             <a:avLst>
@@ -8690,8 +8741,179 @@
         </p:nvSpPr>
         <p:spPr>
           <a:xfrm>
+            <a:off x="8229600" y="3611880"/>
+            <a:ext cx="1691640" cy="1097280"/>
+          </a:xfrm>
+          <a:prstGeom prst="rect">
+            <a:avLst/>
+          </a:prstGeom>
+          <a:noFill/>
+          <a:ln/>
+        </p:spPr>
+        <p:txBody>
+          <a:bodyPr wrap="square" rtlCol="0" anchor="ctr"/>
+          <a:lstStyle/>
+          <a:p>
+            <a:pPr algn="ctr" indent="0" marL="0">
+              <a:buNone/>
+            </a:pPr>
+            <a:r>
+              <a:rPr lang="en-US" sz="1000" dirty="0">
+                <a:solidFill>
+                  <a:srgbClr val="FFFFFF"/>
+                </a:solidFill>
+                <a:latin typeface="Calibri" pitchFamily="34" charset="0"/>
+                <a:ea typeface="Calibri" pitchFamily="34" charset="-122"/>
+                <a:cs typeface="Calibri" pitchFamily="34" charset="-120"/>
+              </a:rPr>
+              <a:t>Negociación</a:t>
+            </a:r>
+            <a:endParaRPr lang="en-US" sz="1000" dirty="0"/>
+          </a:p>
+          <a:p>
+            <a:pPr algn="ctr" indent="0" marL="0">
+              <a:buNone/>
+            </a:pPr>
+            <a:r>
+              <a:rPr lang="en-US" sz="1000" dirty="0">
+                <a:solidFill>
+                  <a:srgbClr val="FFFFFF"/>
+                </a:solidFill>
+                <a:latin typeface="Calibri" pitchFamily="34" charset="0"/>
+                <a:ea typeface="Calibri" pitchFamily="34" charset="-122"/>
+                <a:cs typeface="Calibri" pitchFamily="34" charset="-120"/>
+              </a:rPr>
+              <a:t>hilo</a:t>
+            </a:r>
+            <a:endParaRPr lang="en-US" sz="1000" dirty="0"/>
+          </a:p>
+          <a:p>
+            <a:pPr algn="ctr" indent="0" marL="0">
+              <a:buNone/>
+            </a:pPr>
+            <a:r>
+              <a:rPr lang="en-US" sz="1000" dirty="0">
+                <a:solidFill>
+                  <a:srgbClr val="FFFFFF"/>
+                </a:solidFill>
+                <a:latin typeface="Calibri" pitchFamily="34" charset="0"/>
+                <a:ea typeface="Calibri" pitchFamily="34" charset="-122"/>
+                <a:cs typeface="Calibri" pitchFamily="34" charset="-120"/>
+              </a:rPr>
+              <a:t>condiciones</a:t>
+            </a:r>
+            <a:endParaRPr lang="en-US" sz="1000" dirty="0"/>
+          </a:p>
+        </p:txBody>
+      </p:sp>
+      <p:sp>
+        <p:nvSpPr>
+          <p:cNvPr id="49" name="Shape 47"/>
+          <p:cNvSpPr/>
+          <p:nvPr/>
+        </p:nvSpPr>
+        <p:spPr>
+          <a:xfrm>
+            <a:off x="8119872" y="3502152"/>
+            <a:ext cx="329184" cy="329184"/>
+          </a:xfrm>
+          <a:prstGeom prst="ellipse">
+            <a:avLst/>
+          </a:prstGeom>
+          <a:solidFill>
+            <a:srgbClr val="1A237E"/>
+          </a:solidFill>
+          <a:ln w="25400">
+            <a:solidFill>
+              <a:srgbClr val="FFFFFF"/>
+            </a:solidFill>
+            <a:prstDash val="solid"/>
+          </a:ln>
+        </p:spPr>
+      </p:sp>
+      <p:sp>
+        <p:nvSpPr>
+          <p:cNvPr id="50" name="Text 48"/>
+          <p:cNvSpPr/>
+          <p:nvPr/>
+        </p:nvSpPr>
+        <p:spPr>
+          <a:xfrm>
+            <a:off x="8119872" y="3502152"/>
+            <a:ext cx="329184" cy="329184"/>
+          </a:xfrm>
+          <a:prstGeom prst="rect">
+            <a:avLst/>
+          </a:prstGeom>
+          <a:noFill/>
+          <a:ln/>
+        </p:spPr>
+        <p:txBody>
+          <a:bodyPr wrap="square" rtlCol="0" anchor="ctr"/>
+          <a:lstStyle/>
+          <a:p>
+            <a:pPr algn="ctr" indent="0" marL="0">
+              <a:buNone/>
+            </a:pPr>
+            <a:r>
+              <a:rPr lang="en-US" sz="1000" b="1" dirty="0">
+                <a:solidFill>
+                  <a:srgbClr val="FFFFFF"/>
+                </a:solidFill>
+                <a:latin typeface="Calibri" pitchFamily="34" charset="0"/>
+                <a:ea typeface="Calibri" pitchFamily="34" charset="-122"/>
+                <a:cs typeface="Calibri" pitchFamily="34" charset="-120"/>
+              </a:rPr>
+              <a:t>8</a:t>
+            </a:r>
+            <a:endParaRPr lang="en-US" sz="1000" dirty="0"/>
+          </a:p>
+        </p:txBody>
+      </p:sp>
+      <p:sp>
+        <p:nvSpPr>
+          <p:cNvPr id="51" name="Shape 49"/>
+          <p:cNvSpPr/>
+          <p:nvPr/>
+        </p:nvSpPr>
+        <p:spPr>
+          <a:xfrm>
             <a:off x="10104120" y="3611880"/>
-            <a:ext cx="1737360" cy="1097280"/>
+            <a:ext cx="1691640" cy="1097280"/>
+          </a:xfrm>
+          <a:prstGeom prst="roundRect">
+            <a:avLst>
+              <a:gd name="adj" fmla="val 6667"/>
+            </a:avLst>
+          </a:prstGeom>
+          <a:solidFill>
+            <a:srgbClr val="2E7D32"/>
+          </a:solidFill>
+          <a:ln w="19050">
+            <a:solidFill>
+              <a:srgbClr val="1B5E20"/>
+            </a:solidFill>
+            <a:prstDash val="solid"/>
+          </a:ln>
+          <a:effectLst>
+            <a:outerShdw sx="100000" sy="100000" kx="0" ky="0" algn="bl" rotWithShape="0" blurRad="50800" dist="25400" dir="2700000">
+              <a:srgbClr val="00000022">
+                <a:alpha val="75000"/>
+              </a:srgbClr>
+            </a:outerShdw>
+          </a:effectLst>
+        </p:spPr>
+      </p:sp>
+      <p:sp>
+        <p:nvSpPr>
+          <p:cNvPr id="52" name="Text 50"/>
+          <p:cNvSpPr/>
+          <p:nvPr/>
+        </p:nvSpPr>
+        <p:spPr>
+          <a:xfrm>
+            <a:off x="10104120" y="3611880"/>
+            <a:ext cx="1691640" cy="1097280"/>
           </a:xfrm>
           <a:prstGeom prst="rect">
             <a:avLst/>
@@ -8732,7 +8954,7 @@
                 <a:ea typeface="Calibri" pitchFamily="34" charset="-122"/>
                 <a:cs typeface="Calibri" pitchFamily="34" charset="-120"/>
               </a:rPr>
-              <a:t>Cierre +</a:t>
+              <a:t>cierre +</a:t>
             </a:r>
             <a:endParaRPr lang="en-US" sz="1000" dirty="0"/>
           </a:p>
@@ -8757,7 +8979,7 @@
       </p:sp>
       <p:sp>
         <p:nvSpPr>
-          <p:cNvPr id="49" name="Shape 47"/>
+          <p:cNvPr id="53" name="Shape 51"/>
           <p:cNvSpPr/>
           <p:nvPr/>
         </p:nvSpPr>
@@ -8782,7 +9004,7 @@
       </p:sp>
       <p:sp>
         <p:nvSpPr>
-          <p:cNvPr id="50" name="Text 48"/>
+          <p:cNvPr id="54" name="Text 52"/>
           <p:cNvSpPr/>
           <p:nvPr/>
         </p:nvSpPr>
@@ -8813,30 +9035,30 @@
                 <a:ea typeface="Calibri" pitchFamily="34" charset="-122"/>
                 <a:cs typeface="Calibri" pitchFamily="34" charset="-120"/>
               </a:rPr>
-              <a:t>9</a:t>
-            </a:r>
-            <a:endParaRPr lang="en-US" sz="1000" dirty="0"/>
-          </a:p>
-        </p:txBody>
-      </p:sp>
-      <p:sp>
-        <p:nvSpPr>
-          <p:cNvPr id="51" name="Shape 49"/>
-          <p:cNvSpPr/>
-          <p:nvPr/>
-        </p:nvSpPr>
-        <p:spPr>
-          <a:xfrm>
-            <a:off x="2286000" y="1874520"/>
-            <a:ext cx="320040" cy="0"/>
+              <a:t>10</a:t>
+            </a:r>
+            <a:endParaRPr lang="en-US" sz="1000" dirty="0"/>
+          </a:p>
+        </p:txBody>
+      </p:sp>
+      <p:sp>
+        <p:nvSpPr>
+          <p:cNvPr id="55" name="Shape 53"/>
+          <p:cNvSpPr/>
+          <p:nvPr/>
+        </p:nvSpPr>
+        <p:spPr>
+          <a:xfrm>
+            <a:off x="1280160" y="2423160"/>
+            <a:ext cx="0" cy="1188720"/>
           </a:xfrm>
           <a:prstGeom prst="line">
             <a:avLst/>
           </a:prstGeom>
           <a:noFill/>
-          <a:ln w="22860">
-            <a:solidFill>
-              <a:srgbClr val="BDBDBD"/>
+          <a:ln w="44450">
+            <a:solidFill>
+              <a:srgbClr val="DC2626"/>
             </a:solidFill>
             <a:prstDash val="solid"/>
             <a:tailEnd type="arrow"/>
@@ -8845,336 +9067,14 @@
       </p:sp>
       <p:sp>
         <p:nvSpPr>
-          <p:cNvPr id="52" name="Shape 50"/>
-          <p:cNvSpPr/>
-          <p:nvPr/>
-        </p:nvSpPr>
-        <p:spPr>
-          <a:xfrm>
-            <a:off x="3474720" y="2423160"/>
-            <a:ext cx="-2148840" cy="1188720"/>
-          </a:xfrm>
-          <a:prstGeom prst="line">
-            <a:avLst/>
-          </a:prstGeom>
-          <a:noFill/>
-          <a:ln w="22860">
-            <a:solidFill>
-              <a:srgbClr val="0078D4"/>
-            </a:solidFill>
-            <a:prstDash val="solid"/>
-            <a:tailEnd type="arrow"/>
-          </a:ln>
-        </p:spPr>
-      </p:sp>
-      <p:sp>
-        <p:nvSpPr>
-          <p:cNvPr id="53" name="Text 51"/>
-          <p:cNvSpPr/>
-          <p:nvPr/>
-        </p:nvSpPr>
-        <p:spPr>
-          <a:xfrm>
-            <a:off x="1805940" y="2898648"/>
-            <a:ext cx="1188720" cy="237744"/>
-          </a:xfrm>
-          <a:prstGeom prst="rect">
-            <a:avLst/>
-          </a:prstGeom>
-          <a:solidFill>
-            <a:srgbClr val="FFFFFF">
-              <a:alpha val="80000"/>
-            </a:srgbClr>
-          </a:solidFill>
-          <a:ln/>
-        </p:spPr>
-        <p:txBody>
-          <a:bodyPr wrap="square" rtlCol="0" anchor="ctr"/>
-          <a:lstStyle/>
-          <a:p>
-            <a:pPr algn="ctr" indent="0" marL="0">
-              <a:buNone/>
-            </a:pPr>
-            <a:r>
-              <a:rPr lang="en-US" sz="800" i="1" dirty="0">
-                <a:solidFill>
-                  <a:srgbClr val="555555"/>
-                </a:solidFill>
-                <a:latin typeface="Calibri" pitchFamily="34" charset="0"/>
-                <a:ea typeface="Calibri" pitchFamily="34" charset="-122"/>
-                <a:cs typeface="Calibri" pitchFamily="34" charset="-120"/>
-              </a:rPr>
-              <a:t>sync</a:t>
-            </a:r>
-            <a:endParaRPr lang="en-US" sz="800" dirty="0"/>
-          </a:p>
-        </p:txBody>
-      </p:sp>
-      <p:sp>
-        <p:nvSpPr>
-          <p:cNvPr id="54" name="Shape 52"/>
-          <p:cNvSpPr/>
-          <p:nvPr/>
-        </p:nvSpPr>
-        <p:spPr>
-          <a:xfrm>
-            <a:off x="2103120" y="4160520"/>
-            <a:ext cx="228600" cy="0"/>
-          </a:xfrm>
-          <a:prstGeom prst="line">
-            <a:avLst/>
-          </a:prstGeom>
-          <a:noFill/>
-          <a:ln w="22860">
-            <a:solidFill>
-              <a:srgbClr val="BDBDBD"/>
-            </a:solidFill>
-            <a:prstDash val="solid"/>
-            <a:tailEnd type="arrow"/>
-          </a:ln>
-        </p:spPr>
-      </p:sp>
-      <p:sp>
-        <p:nvSpPr>
-          <p:cNvPr id="55" name="Shape 53"/>
-          <p:cNvSpPr/>
-          <p:nvPr/>
-        </p:nvSpPr>
-        <p:spPr>
-          <a:xfrm>
-            <a:off x="3886200" y="4160520"/>
-            <a:ext cx="228600" cy="0"/>
-          </a:xfrm>
-          <a:prstGeom prst="line">
-            <a:avLst/>
-          </a:prstGeom>
-          <a:noFill/>
-          <a:ln w="22860">
-            <a:solidFill>
-              <a:srgbClr val="BDBDBD"/>
-            </a:solidFill>
-            <a:prstDash val="solid"/>
-            <a:tailEnd type="arrow"/>
-          </a:ln>
-        </p:spPr>
-      </p:sp>
-      <p:sp>
-        <p:nvSpPr>
           <p:cNvPr id="56" name="Shape 54"/>
           <p:cNvSpPr/>
           <p:nvPr/>
         </p:nvSpPr>
         <p:spPr>
           <a:xfrm>
-            <a:off x="5669280" y="4160520"/>
-            <a:ext cx="228600" cy="0"/>
-          </a:xfrm>
-          <a:prstGeom prst="line">
-            <a:avLst/>
-          </a:prstGeom>
-          <a:noFill/>
-          <a:ln w="22860">
-            <a:solidFill>
-              <a:srgbClr val="BDBDBD"/>
-            </a:solidFill>
-            <a:prstDash val="solid"/>
-            <a:tailEnd type="arrow"/>
-          </a:ln>
-        </p:spPr>
-      </p:sp>
-      <p:sp>
-        <p:nvSpPr>
-          <p:cNvPr id="57" name="Shape 55"/>
-          <p:cNvSpPr/>
-          <p:nvPr/>
-        </p:nvSpPr>
-        <p:spPr>
-          <a:xfrm>
-            <a:off x="7452360" y="4160520"/>
-            <a:ext cx="228600" cy="0"/>
-          </a:xfrm>
-          <a:prstGeom prst="line">
-            <a:avLst/>
-          </a:prstGeom>
-          <a:noFill/>
-          <a:ln w="22860">
-            <a:solidFill>
-              <a:srgbClr val="BDBDBD"/>
-            </a:solidFill>
-            <a:prstDash val="solid"/>
-            <a:tailEnd type="arrow"/>
-          </a:ln>
-        </p:spPr>
-      </p:sp>
-      <p:sp>
-        <p:nvSpPr>
-          <p:cNvPr id="58" name="Shape 56"/>
-          <p:cNvSpPr/>
-          <p:nvPr/>
-        </p:nvSpPr>
-        <p:spPr>
-          <a:xfrm>
-            <a:off x="8503920" y="3611880"/>
-            <a:ext cx="1051560" cy="-1188720"/>
-          </a:xfrm>
-          <a:prstGeom prst="line">
-            <a:avLst/>
-          </a:prstGeom>
-          <a:noFill/>
-          <a:ln w="22860">
-            <a:solidFill>
-              <a:srgbClr val="7C3AED"/>
-            </a:solidFill>
-            <a:prstDash val="solid"/>
-            <a:tailEnd type="arrow"/>
-          </a:ln>
-        </p:spPr>
-      </p:sp>
-      <p:sp>
-        <p:nvSpPr>
-          <p:cNvPr id="59" name="Text 57"/>
-          <p:cNvSpPr/>
-          <p:nvPr/>
-        </p:nvSpPr>
-        <p:spPr>
-          <a:xfrm>
-            <a:off x="8435340" y="2898648"/>
-            <a:ext cx="1188720" cy="237744"/>
-          </a:xfrm>
-          <a:prstGeom prst="rect">
-            <a:avLst/>
-          </a:prstGeom>
-          <a:solidFill>
-            <a:srgbClr val="FFFFFF">
-              <a:alpha val="80000"/>
-            </a:srgbClr>
-          </a:solidFill>
-          <a:ln/>
-        </p:spPr>
-        <p:txBody>
-          <a:bodyPr wrap="square" rtlCol="0" anchor="ctr"/>
-          <a:lstStyle/>
-          <a:p>
-            <a:pPr algn="ctr" indent="0" marL="0">
-              <a:buNone/>
-            </a:pPr>
-            <a:r>
-              <a:rPr lang="en-US" sz="800" i="1" dirty="0">
-                <a:solidFill>
-                  <a:srgbClr val="555555"/>
-                </a:solidFill>
-                <a:latin typeface="Calibri" pitchFamily="34" charset="0"/>
-                <a:ea typeface="Calibri" pitchFamily="34" charset="-122"/>
-                <a:cs typeface="Calibri" pitchFamily="34" charset="-120"/>
-              </a:rPr>
-              <a:t>handoff</a:t>
-            </a:r>
-            <a:endParaRPr lang="en-US" sz="800" dirty="0"/>
-          </a:p>
-        </p:txBody>
-      </p:sp>
-      <p:sp>
-        <p:nvSpPr>
-          <p:cNvPr id="60" name="Shape 58"/>
-          <p:cNvSpPr/>
-          <p:nvPr/>
-        </p:nvSpPr>
-        <p:spPr>
-          <a:xfrm>
-            <a:off x="9555480" y="2423160"/>
-            <a:ext cx="1417320" cy="1188720"/>
-          </a:xfrm>
-          <a:prstGeom prst="line">
-            <a:avLst/>
-          </a:prstGeom>
-          <a:noFill/>
-          <a:ln w="22860">
-            <a:solidFill>
-              <a:srgbClr val="0078D4"/>
-            </a:solidFill>
-            <a:prstDash val="solid"/>
-            <a:tailEnd type="arrow"/>
-          </a:ln>
-        </p:spPr>
-      </p:sp>
-      <p:sp>
-        <p:nvSpPr>
-          <p:cNvPr id="61" name="Text 59"/>
-          <p:cNvSpPr/>
-          <p:nvPr/>
-        </p:nvSpPr>
-        <p:spPr>
-          <a:xfrm>
-            <a:off x="9669780" y="2898648"/>
-            <a:ext cx="1188720" cy="237744"/>
-          </a:xfrm>
-          <a:prstGeom prst="rect">
-            <a:avLst/>
-          </a:prstGeom>
-          <a:solidFill>
-            <a:srgbClr val="FFFFFF">
-              <a:alpha val="80000"/>
-            </a:srgbClr>
-          </a:solidFill>
-          <a:ln/>
-        </p:spPr>
-        <p:txBody>
-          <a:bodyPr wrap="square" rtlCol="0" anchor="ctr"/>
-          <a:lstStyle/>
-          <a:p>
-            <a:pPr algn="ctr" indent="0" marL="0">
-              <a:buNone/>
-            </a:pPr>
-            <a:r>
-              <a:rPr lang="en-US" sz="800" i="1" dirty="0">
-                <a:solidFill>
-                  <a:srgbClr val="555555"/>
-                </a:solidFill>
-                <a:latin typeface="Calibri" pitchFamily="34" charset="0"/>
-                <a:ea typeface="Calibri" pitchFamily="34" charset="-122"/>
-                <a:cs typeface="Calibri" pitchFamily="34" charset="-120"/>
-              </a:rPr>
-              <a:t>sync</a:t>
-            </a:r>
-            <a:endParaRPr lang="en-US" sz="800" dirty="0"/>
-          </a:p>
-        </p:txBody>
-      </p:sp>
-      <p:sp>
-        <p:nvSpPr>
-          <p:cNvPr id="62" name="Shape 60"/>
-          <p:cNvSpPr/>
-          <p:nvPr/>
-        </p:nvSpPr>
-        <p:spPr>
-          <a:xfrm>
-            <a:off x="1417320" y="2423160"/>
-            <a:ext cx="1691640" cy="1188720"/>
-          </a:xfrm>
-          <a:prstGeom prst="line">
-            <a:avLst/>
-          </a:prstGeom>
-          <a:noFill/>
-          <a:ln w="44450">
-            <a:solidFill>
-              <a:srgbClr val="DC2626"/>
-            </a:solidFill>
-            <a:prstDash val="solid"/>
-            <a:headEnd type="arrow"/>
-            <a:tailEnd type="arrow"/>
-          </a:ln>
-        </p:spPr>
-      </p:sp>
-      <p:sp>
-        <p:nvSpPr>
-          <p:cNvPr id="63" name="Shape 61"/>
-          <p:cNvSpPr/>
-          <p:nvPr/>
-        </p:nvSpPr>
-        <p:spPr>
-          <a:xfrm>
             <a:off x="365760" y="2788920"/>
-            <a:ext cx="2331720" cy="292608"/>
+            <a:ext cx="1874520" cy="292608"/>
           </a:xfrm>
           <a:prstGeom prst="roundRect">
             <a:avLst>
@@ -9194,19 +9094,225 @@
       </p:sp>
       <p:sp>
         <p:nvSpPr>
+          <p:cNvPr id="57" name="Text 55"/>
+          <p:cNvSpPr/>
+          <p:nvPr/>
+        </p:nvSpPr>
+        <p:spPr>
+          <a:xfrm>
+            <a:off x="365760" y="2788920"/>
+            <a:ext cx="1874520" cy="292608"/>
+          </a:xfrm>
+          <a:prstGeom prst="rect">
+            <a:avLst/>
+          </a:prstGeom>
+          <a:noFill/>
+          <a:ln/>
+        </p:spPr>
+        <p:txBody>
+          <a:bodyPr wrap="square" rtlCol="0" anchor="ctr"/>
+          <a:lstStyle/>
+          <a:p>
+            <a:pPr algn="ctr" indent="0" marL="0">
+              <a:buNone/>
+            </a:pPr>
+            <a:r>
+              <a:rPr lang="en-US" sz="900" b="1" dirty="0">
+                <a:solidFill>
+                  <a:srgbClr val="991B1B"/>
+                </a:solidFill>
+                <a:latin typeface="Calibri" pitchFamily="34" charset="0"/>
+                <a:ea typeface="Calibri" pitchFamily="34" charset="-122"/>
+                <a:cs typeface="Calibri" pitchFamily="34" charset="-120"/>
+              </a:rPr>
+              <a:t>🔗 FK · CRÍTICO</a:t>
+            </a:r>
+            <a:endParaRPr lang="en-US" sz="900" dirty="0"/>
+          </a:p>
+        </p:txBody>
+      </p:sp>
+      <p:sp>
+        <p:nvSpPr>
+          <p:cNvPr id="58" name="Shape 56"/>
+          <p:cNvSpPr/>
+          <p:nvPr/>
+        </p:nvSpPr>
+        <p:spPr>
+          <a:xfrm>
+            <a:off x="2148840" y="4160520"/>
+            <a:ext cx="182880" cy="0"/>
+          </a:xfrm>
+          <a:prstGeom prst="line">
+            <a:avLst/>
+          </a:prstGeom>
+          <a:noFill/>
+          <a:ln w="22860">
+            <a:solidFill>
+              <a:srgbClr val="BDBDBD"/>
+            </a:solidFill>
+            <a:prstDash val="solid"/>
+            <a:tailEnd type="arrow"/>
+          </a:ln>
+        </p:spPr>
+      </p:sp>
+      <p:sp>
+        <p:nvSpPr>
+          <p:cNvPr id="59" name="Shape 57"/>
+          <p:cNvSpPr/>
+          <p:nvPr/>
+        </p:nvSpPr>
+        <p:spPr>
+          <a:xfrm>
+            <a:off x="5029200" y="2423160"/>
+            <a:ext cx="0" cy="1188720"/>
+          </a:xfrm>
+          <a:prstGeom prst="line">
+            <a:avLst/>
+          </a:prstGeom>
+          <a:noFill/>
+          <a:ln w="22860">
+            <a:solidFill>
+              <a:srgbClr val="1E40AF"/>
+            </a:solidFill>
+            <a:prstDash val="solid"/>
+            <a:tailEnd type="arrow"/>
+          </a:ln>
+        </p:spPr>
+      </p:sp>
+      <p:sp>
+        <p:nvSpPr>
+          <p:cNvPr id="60" name="Text 58"/>
+          <p:cNvSpPr/>
+          <p:nvPr/>
+        </p:nvSpPr>
+        <p:spPr>
+          <a:xfrm>
+            <a:off x="4434840" y="2898648"/>
+            <a:ext cx="1188720" cy="237744"/>
+          </a:xfrm>
+          <a:prstGeom prst="rect">
+            <a:avLst/>
+          </a:prstGeom>
+          <a:solidFill>
+            <a:srgbClr val="FFFFFF">
+              <a:alpha val="80000"/>
+            </a:srgbClr>
+          </a:solidFill>
+          <a:ln/>
+        </p:spPr>
+        <p:txBody>
+          <a:bodyPr wrap="square" rtlCol="0" anchor="ctr"/>
+          <a:lstStyle/>
+          <a:p>
+            <a:pPr algn="ctr" indent="0" marL="0">
+              <a:buNone/>
+            </a:pPr>
+            <a:r>
+              <a:rPr lang="en-US" sz="800" i="1" dirty="0">
+                <a:solidFill>
+                  <a:srgbClr val="555555"/>
+                </a:solidFill>
+                <a:latin typeface="Calibri" pitchFamily="34" charset="0"/>
+                <a:ea typeface="Calibri" pitchFamily="34" charset="-122"/>
+                <a:cs typeface="Calibri" pitchFamily="34" charset="-120"/>
+              </a:rPr>
+              <a:t>FK</a:t>
+            </a:r>
+            <a:endParaRPr lang="en-US" sz="800" dirty="0"/>
+          </a:p>
+        </p:txBody>
+      </p:sp>
+      <p:sp>
+        <p:nvSpPr>
+          <p:cNvPr id="61" name="Shape 59"/>
+          <p:cNvSpPr/>
+          <p:nvPr/>
+        </p:nvSpPr>
+        <p:spPr>
+          <a:xfrm>
+            <a:off x="4023360" y="4160520"/>
+            <a:ext cx="1965960" cy="-91440"/>
+          </a:xfrm>
+          <a:prstGeom prst="line">
+            <a:avLst/>
+          </a:prstGeom>
+          <a:noFill/>
+          <a:ln w="22860">
+            <a:solidFill>
+              <a:srgbClr val="BDBDBD"/>
+            </a:solidFill>
+            <a:prstDash val="solid"/>
+            <a:tailEnd type="arrow"/>
+          </a:ln>
+        </p:spPr>
+      </p:sp>
+      <p:sp>
+        <p:nvSpPr>
+          <p:cNvPr id="62" name="Shape 60"/>
+          <p:cNvSpPr/>
+          <p:nvPr/>
+        </p:nvSpPr>
+        <p:spPr>
+          <a:xfrm>
+            <a:off x="5852160" y="4160520"/>
+            <a:ext cx="137160" cy="91440"/>
+          </a:xfrm>
+          <a:prstGeom prst="line">
+            <a:avLst/>
+          </a:prstGeom>
+          <a:noFill/>
+          <a:ln w="22860">
+            <a:solidFill>
+              <a:srgbClr val="BDBDBD"/>
+            </a:solidFill>
+            <a:prstDash val="solid"/>
+            <a:tailEnd type="arrow"/>
+          </a:ln>
+        </p:spPr>
+      </p:sp>
+      <p:sp>
+        <p:nvSpPr>
+          <p:cNvPr id="63" name="Shape 61"/>
+          <p:cNvSpPr/>
+          <p:nvPr/>
+        </p:nvSpPr>
+        <p:spPr>
+          <a:xfrm>
+            <a:off x="7178040" y="3611880"/>
+            <a:ext cx="914400" cy="-1188720"/>
+          </a:xfrm>
+          <a:prstGeom prst="line">
+            <a:avLst/>
+          </a:prstGeom>
+          <a:noFill/>
+          <a:ln w="22860">
+            <a:solidFill>
+              <a:srgbClr val="7C3AED"/>
+            </a:solidFill>
+            <a:prstDash val="solid"/>
+            <a:tailEnd type="arrow"/>
+          </a:ln>
+        </p:spPr>
+      </p:sp>
+      <p:sp>
+        <p:nvSpPr>
           <p:cNvPr id="64" name="Text 62"/>
           <p:cNvSpPr/>
           <p:nvPr/>
         </p:nvSpPr>
         <p:spPr>
           <a:xfrm>
-            <a:off x="365760" y="2788920"/>
-            <a:ext cx="2331720" cy="292608"/>
-          </a:xfrm>
-          <a:prstGeom prst="rect">
-            <a:avLst/>
-          </a:prstGeom>
-          <a:noFill/>
+            <a:off x="7040880" y="2898648"/>
+            <a:ext cx="1188720" cy="237744"/>
+          </a:xfrm>
+          <a:prstGeom prst="rect">
+            <a:avLst/>
+          </a:prstGeom>
+          <a:solidFill>
+            <a:srgbClr val="FFFFFF">
+              <a:alpha val="80000"/>
+            </a:srgbClr>
+          </a:solidFill>
           <a:ln/>
         </p:spPr>
         <p:txBody>
@@ -9217,23 +9323,224 @@
               <a:buNone/>
             </a:pPr>
             <a:r>
-              <a:rPr lang="en-US" sz="900" b="1" dirty="0">
-                <a:solidFill>
-                  <a:srgbClr val="991B1B"/>
-                </a:solidFill>
-                <a:latin typeface="Calibri" pitchFamily="34" charset="0"/>
-                <a:ea typeface="Calibri" pitchFamily="34" charset="-122"/>
-                <a:cs typeface="Calibri" pitchFamily="34" charset="-120"/>
-              </a:rPr>
-              <a:t>🔗 vínculo Cuenta-Propietario · CRÍTICO</a:t>
-            </a:r>
-            <a:endParaRPr lang="en-US" sz="900" dirty="0"/>
+              <a:rPr lang="en-US" sz="800" i="1" dirty="0">
+                <a:solidFill>
+                  <a:srgbClr val="555555"/>
+                </a:solidFill>
+                <a:latin typeface="Calibri" pitchFamily="34" charset="0"/>
+                <a:ea typeface="Calibri" pitchFamily="34" charset="-122"/>
+                <a:cs typeface="Calibri" pitchFamily="34" charset="-120"/>
+              </a:rPr>
+              <a:t>handoff #1</a:t>
+            </a:r>
+            <a:endParaRPr lang="en-US" sz="800" dirty="0"/>
           </a:p>
         </p:txBody>
       </p:sp>
       <p:sp>
         <p:nvSpPr>
           <p:cNvPr id="65" name="Shape 63"/>
+          <p:cNvSpPr/>
+          <p:nvPr/>
+        </p:nvSpPr>
+        <p:spPr>
+          <a:xfrm>
+            <a:off x="8092440" y="2423160"/>
+            <a:ext cx="685800" cy="1188720"/>
+          </a:xfrm>
+          <a:prstGeom prst="line">
+            <a:avLst/>
+          </a:prstGeom>
+          <a:noFill/>
+          <a:ln w="22860">
+            <a:solidFill>
+              <a:srgbClr val="0078D4"/>
+            </a:solidFill>
+            <a:prstDash val="solid"/>
+            <a:tailEnd type="arrow"/>
+          </a:ln>
+        </p:spPr>
+      </p:sp>
+      <p:sp>
+        <p:nvSpPr>
+          <p:cNvPr id="66" name="Text 64"/>
+          <p:cNvSpPr/>
+          <p:nvPr/>
+        </p:nvSpPr>
+        <p:spPr>
+          <a:xfrm>
+            <a:off x="7840980" y="2898648"/>
+            <a:ext cx="1188720" cy="237744"/>
+          </a:xfrm>
+          <a:prstGeom prst="rect">
+            <a:avLst/>
+          </a:prstGeom>
+          <a:solidFill>
+            <a:srgbClr val="FFFFFF">
+              <a:alpha val="80000"/>
+            </a:srgbClr>
+          </a:solidFill>
+          <a:ln/>
+        </p:spPr>
+        <p:txBody>
+          <a:bodyPr wrap="square" rtlCol="0" anchor="ctr"/>
+          <a:lstStyle/>
+          <a:p>
+            <a:pPr algn="ctr" indent="0" marL="0">
+              <a:buNone/>
+            </a:pPr>
+            <a:r>
+              <a:rPr lang="en-US" sz="800" i="1" dirty="0">
+                <a:solidFill>
+                  <a:srgbClr val="555555"/>
+                </a:solidFill>
+                <a:latin typeface="Calibri" pitchFamily="34" charset="0"/>
+                <a:ea typeface="Calibri" pitchFamily="34" charset="-122"/>
+                <a:cs typeface="Calibri" pitchFamily="34" charset="-120"/>
+              </a:rPr>
+              <a:t>sync</a:t>
+            </a:r>
+            <a:endParaRPr lang="en-US" sz="800" dirty="0"/>
+          </a:p>
+        </p:txBody>
+      </p:sp>
+      <p:sp>
+        <p:nvSpPr>
+          <p:cNvPr id="67" name="Shape 65"/>
+          <p:cNvSpPr/>
+          <p:nvPr/>
+        </p:nvSpPr>
+        <p:spPr>
+          <a:xfrm>
+            <a:off x="9921240" y="3611880"/>
+            <a:ext cx="1005840" cy="-1188720"/>
+          </a:xfrm>
+          <a:prstGeom prst="line">
+            <a:avLst/>
+          </a:prstGeom>
+          <a:noFill/>
+          <a:ln w="22860">
+            <a:solidFill>
+              <a:srgbClr val="7C3AED"/>
+            </a:solidFill>
+            <a:prstDash val="solid"/>
+            <a:tailEnd type="arrow"/>
+          </a:ln>
+        </p:spPr>
+      </p:sp>
+      <p:sp>
+        <p:nvSpPr>
+          <p:cNvPr id="68" name="Text 66"/>
+          <p:cNvSpPr/>
+          <p:nvPr/>
+        </p:nvSpPr>
+        <p:spPr>
+          <a:xfrm>
+            <a:off x="9829800" y="2898648"/>
+            <a:ext cx="1188720" cy="237744"/>
+          </a:xfrm>
+          <a:prstGeom prst="rect">
+            <a:avLst/>
+          </a:prstGeom>
+          <a:solidFill>
+            <a:srgbClr val="FFFFFF">
+              <a:alpha val="80000"/>
+            </a:srgbClr>
+          </a:solidFill>
+          <a:ln/>
+        </p:spPr>
+        <p:txBody>
+          <a:bodyPr wrap="square" rtlCol="0" anchor="ctr"/>
+          <a:lstStyle/>
+          <a:p>
+            <a:pPr algn="ctr" indent="0" marL="0">
+              <a:buNone/>
+            </a:pPr>
+            <a:r>
+              <a:rPr lang="en-US" sz="800" i="1" dirty="0">
+                <a:solidFill>
+                  <a:srgbClr val="555555"/>
+                </a:solidFill>
+                <a:latin typeface="Calibri" pitchFamily="34" charset="0"/>
+                <a:ea typeface="Calibri" pitchFamily="34" charset="-122"/>
+                <a:cs typeface="Calibri" pitchFamily="34" charset="-120"/>
+              </a:rPr>
+              <a:t>handoff #2</a:t>
+            </a:r>
+            <a:endParaRPr lang="en-US" sz="800" dirty="0"/>
+          </a:p>
+        </p:txBody>
+      </p:sp>
+      <p:sp>
+        <p:nvSpPr>
+          <p:cNvPr id="69" name="Shape 67"/>
+          <p:cNvSpPr/>
+          <p:nvPr/>
+        </p:nvSpPr>
+        <p:spPr>
+          <a:xfrm>
+            <a:off x="10927080" y="2423160"/>
+            <a:ext cx="0" cy="1188720"/>
+          </a:xfrm>
+          <a:prstGeom prst="line">
+            <a:avLst/>
+          </a:prstGeom>
+          <a:noFill/>
+          <a:ln w="22860">
+            <a:solidFill>
+              <a:srgbClr val="0078D4"/>
+            </a:solidFill>
+            <a:prstDash val="solid"/>
+            <a:tailEnd type="arrow"/>
+          </a:ln>
+        </p:spPr>
+      </p:sp>
+      <p:sp>
+        <p:nvSpPr>
+          <p:cNvPr id="70" name="Text 68"/>
+          <p:cNvSpPr/>
+          <p:nvPr/>
+        </p:nvSpPr>
+        <p:spPr>
+          <a:xfrm>
+            <a:off x="10332720" y="2898648"/>
+            <a:ext cx="1188720" cy="237744"/>
+          </a:xfrm>
+          <a:prstGeom prst="rect">
+            <a:avLst/>
+          </a:prstGeom>
+          <a:solidFill>
+            <a:srgbClr val="FFFFFF">
+              <a:alpha val="80000"/>
+            </a:srgbClr>
+          </a:solidFill>
+          <a:ln/>
+        </p:spPr>
+        <p:txBody>
+          <a:bodyPr wrap="square" rtlCol="0" anchor="ctr"/>
+          <a:lstStyle/>
+          <a:p>
+            <a:pPr algn="ctr" indent="0" marL="0">
+              <a:buNone/>
+            </a:pPr>
+            <a:r>
+              <a:rPr lang="en-US" sz="800" i="1" dirty="0">
+                <a:solidFill>
+                  <a:srgbClr val="555555"/>
+                </a:solidFill>
+                <a:latin typeface="Calibri" pitchFamily="34" charset="0"/>
+                <a:ea typeface="Calibri" pitchFamily="34" charset="-122"/>
+                <a:cs typeface="Calibri" pitchFamily="34" charset="-120"/>
+              </a:rPr>
+              <a:t>sync</a:t>
+            </a:r>
+            <a:endParaRPr lang="en-US" sz="800" dirty="0"/>
+          </a:p>
+        </p:txBody>
+      </p:sp>
+      <p:sp>
+        <p:nvSpPr>
+          <p:cNvPr id="71" name="Shape 69"/>
           <p:cNvSpPr/>
           <p:nvPr/>
         </p:nvSpPr>
@@ -9258,7 +9565,7 @@
       </p:sp>
       <p:sp>
         <p:nvSpPr>
-          <p:cNvPr id="66" name="Text 64"/>
+          <p:cNvPr id="72" name="Text 70"/>
           <p:cNvSpPr/>
           <p:nvPr/>
         </p:nvSpPr>
@@ -9292,7 +9599,7 @@
                 <a:ea typeface="Calibri" pitchFamily="34" charset="-122"/>
                 <a:cs typeface="Calibri" pitchFamily="34" charset="-120"/>
               </a:rPr>
-              <a:t>El ciclo arranca en Dynamics con el alta de la Cuenta (1) y la detección de la Oportunidad (2). Una vez sincronizada al PDB, se cualifica como Demanda (3) y se conecta con uno o varios Activos (4). Se ejecutan Visitas (5), se formaliza la Oferta (6) y se abre la Negociación (7). El acuerdo final se devuelve a Dynamics como Instrucción (8), y el cierre se registra como Transacción (9). El vínculo Activo ↔ Cuenta-Propietario atraviesa todo el ciclo: sin él, el flujo se rompe.</a:t>
+              <a:t>El ciclo arranca con la Cuenta-Propietario (1) en Dynamics, sobre la que se da de alta el Activo (2) en PDB con FK obligatorio. Sobre el activo se publica una Oferta (3) — el producto disponible al mercado. Por el otro lado, una Cuenta-Arrendatario (4) genera una Demanda (5) en PDB. El sistema realiza el match Oferta ↔ Demanda (6), y cuando hay tracción real se ejecuta el handoff #1 a Dynamics creando la Oportunidad WIP (7). Baja a Negociación (8) en PDB; el acuerdo final dispara el handoff #2 como Instrucción (9), y el cierre se registra como Transacción (10). La Oportunidad NO es el origen del ciclo: es el WIP intermedio que aparece tras el match.</a:t>
             </a:r>
             <a:endParaRPr lang="en-US" sz="1000" dirty="0"/>
           </a:p>
@@ -11685,7 +11992,7 @@
                 <a:ea typeface="Calibri" pitchFamily="34" charset="-122"/>
                 <a:cs typeface="Calibri" pitchFamily="34" charset="-120"/>
               </a:rPr>
-              <a:t>Oportunidades</a:t>
+              <a:t>Oportunidades (WIP)</a:t>
             </a:r>
             <a:endParaRPr lang="en-US" sz="2200" dirty="0"/>
           </a:p>
@@ -11747,7 +12054,7 @@
                 <a:ea typeface="Calibri" pitchFamily="34" charset="-122"/>
                 <a:cs typeface="Calibri" pitchFamily="34" charset="-120"/>
               </a:rPr>
-              <a:t>Detección → cualificación → conversión a Demanda → seguimiento → cierre · Trazabilidad bidireccional</a:t>
+              <a:t>Match Oferta↔Demanda → handoff Dynamics → seguimiento WIP en PDB → avanza a Negociación o cierre Perdida</a:t>
             </a:r>
             <a:endParaRPr lang="en-US" sz="1000" dirty="0"/>
           </a:p>
@@ -11894,7 +12201,73 @@
         <p:spPr>
           <a:xfrm>
             <a:off x="274320" y="914400"/>
-            <a:ext cx="5669280" cy="4572000"/>
+            <a:ext cx="11640312" cy="1691640"/>
+          </a:xfrm>
+          <a:prstGeom prst="rect">
+            <a:avLst/>
+          </a:prstGeom>
+          <a:solidFill>
+            <a:srgbClr val="2E7D32">
+              <a:alpha val="12000"/>
+            </a:srgbClr>
+          </a:solidFill>
+          <a:ln w="12700">
+            <a:solidFill>
+              <a:srgbClr val="2E7D32"/>
+            </a:solidFill>
+            <a:prstDash val="dash"/>
+          </a:ln>
+        </p:spPr>
+      </p:sp>
+      <p:sp>
+        <p:nvSpPr>
+          <p:cNvPr id="12" name="Text 10"/>
+          <p:cNvSpPr/>
+          <p:nvPr/>
+        </p:nvSpPr>
+        <p:spPr>
+          <a:xfrm>
+            <a:off x="347472" y="950976"/>
+            <a:ext cx="11494008" cy="219456"/>
+          </a:xfrm>
+          <a:prstGeom prst="rect">
+            <a:avLst/>
+          </a:prstGeom>
+          <a:noFill/>
+          <a:ln/>
+        </p:spPr>
+        <p:txBody>
+          <a:bodyPr wrap="square" rtlCol="0" anchor="t"/>
+          <a:lstStyle/>
+          <a:p>
+            <a:pPr indent="0" marL="0">
+              <a:buNone/>
+            </a:pPr>
+            <a:r>
+              <a:rPr lang="en-US" sz="900" b="1" dirty="0">
+                <a:solidFill>
+                  <a:srgbClr val="2E7D32"/>
+                </a:solidFill>
+                <a:latin typeface="Calibri" pitchFamily="34" charset="0"/>
+                <a:ea typeface="Calibri" pitchFamily="34" charset="-122"/>
+                <a:cs typeface="Calibri" pitchFamily="34" charset="-120"/>
+              </a:rPr>
+              <a:t>🟢  PDB · Sistema operativo (origen y seguimiento)</a:t>
+            </a:r>
+            <a:endParaRPr lang="en-US" sz="900" dirty="0"/>
+          </a:p>
+        </p:txBody>
+      </p:sp>
+      <p:sp>
+        <p:nvSpPr>
+          <p:cNvPr id="13" name="Shape 11"/>
+          <p:cNvSpPr/>
+          <p:nvPr/>
+        </p:nvSpPr>
+        <p:spPr>
+          <a:xfrm>
+            <a:off x="274320" y="3154680"/>
+            <a:ext cx="11640312" cy="2331720"/>
           </a:xfrm>
           <a:prstGeom prst="rect">
             <a:avLst/>
@@ -11914,14 +12287,14 @@
       </p:sp>
       <p:sp>
         <p:nvSpPr>
-          <p:cNvPr id="12" name="Text 10"/>
-          <p:cNvSpPr/>
-          <p:nvPr/>
-        </p:nvSpPr>
-        <p:spPr>
-          <a:xfrm>
-            <a:off x="347472" y="950976"/>
-            <a:ext cx="5522976" cy="219456"/>
+          <p:cNvPr id="14" name="Text 12"/>
+          <p:cNvSpPr/>
+          <p:nvPr/>
+        </p:nvSpPr>
+        <p:spPr>
+          <a:xfrm>
+            <a:off x="347472" y="3191256"/>
+            <a:ext cx="11494008" cy="219456"/>
           </a:xfrm>
           <a:prstGeom prst="rect">
             <a:avLst/>
@@ -11945,7 +12318,7 @@
                 <a:ea typeface="Calibri" pitchFamily="34" charset="-122"/>
                 <a:cs typeface="Calibri" pitchFamily="34" charset="-120"/>
               </a:rPr>
-              <a:t>☁️  DYNAMICS</a:t>
+              <a:t>☁️  DYNAMICS · Sistema maestro (handoff #1)</a:t>
             </a:r>
             <a:endParaRPr lang="en-US" sz="900" dirty="0"/>
           </a:p>
@@ -11953,92 +12326,26 @@
       </p:sp>
       <p:sp>
         <p:nvSpPr>
-          <p:cNvPr id="13" name="Shape 11"/>
-          <p:cNvSpPr/>
-          <p:nvPr/>
-        </p:nvSpPr>
-        <p:spPr>
-          <a:xfrm>
-            <a:off x="6126480" y="914400"/>
-            <a:ext cx="5788152" cy="4572000"/>
-          </a:xfrm>
-          <a:prstGeom prst="rect">
-            <a:avLst/>
-          </a:prstGeom>
-          <a:solidFill>
-            <a:srgbClr val="2E7D32">
-              <a:alpha val="12000"/>
-            </a:srgbClr>
-          </a:solidFill>
-          <a:ln w="12700">
-            <a:solidFill>
-              <a:srgbClr val="2E7D32"/>
-            </a:solidFill>
-            <a:prstDash val="dash"/>
-          </a:ln>
-        </p:spPr>
-      </p:sp>
-      <p:sp>
-        <p:nvSpPr>
-          <p:cNvPr id="14" name="Text 12"/>
-          <p:cNvSpPr/>
-          <p:nvPr/>
-        </p:nvSpPr>
-        <p:spPr>
-          <a:xfrm>
-            <a:off x="6199632" y="950976"/>
-            <a:ext cx="5641848" cy="219456"/>
-          </a:xfrm>
-          <a:prstGeom prst="rect">
-            <a:avLst/>
-          </a:prstGeom>
-          <a:noFill/>
-          <a:ln/>
-        </p:spPr>
-        <p:txBody>
-          <a:bodyPr wrap="square" rtlCol="0" anchor="t"/>
-          <a:lstStyle/>
-          <a:p>
-            <a:pPr indent="0" marL="0">
-              <a:buNone/>
-            </a:pPr>
-            <a:r>
-              <a:rPr lang="en-US" sz="900" b="1" dirty="0">
-                <a:solidFill>
-                  <a:srgbClr val="2E7D32"/>
-                </a:solidFill>
-                <a:latin typeface="Calibri" pitchFamily="34" charset="0"/>
-                <a:ea typeface="Calibri" pitchFamily="34" charset="-122"/>
-                <a:cs typeface="Calibri" pitchFamily="34" charset="-120"/>
-              </a:rPr>
-              <a:t>🟢  PDB</a:t>
-            </a:r>
-            <a:endParaRPr lang="en-US" sz="900" dirty="0"/>
-          </a:p>
-        </p:txBody>
-      </p:sp>
-      <p:sp>
-        <p:nvSpPr>
           <p:cNvPr id="15" name="Shape 13"/>
           <p:cNvSpPr/>
           <p:nvPr/>
         </p:nvSpPr>
         <p:spPr>
           <a:xfrm>
-            <a:off x="548640" y="1463040"/>
-            <a:ext cx="2377440" cy="914400"/>
+            <a:off x="457200" y="1325880"/>
+            <a:ext cx="1691640" cy="1097280"/>
           </a:xfrm>
           <a:prstGeom prst="roundRect">
             <a:avLst>
-              <a:gd name="adj" fmla="val 8000"/>
+              <a:gd name="adj" fmla="val 6667"/>
             </a:avLst>
           </a:prstGeom>
           <a:solidFill>
-            <a:srgbClr val="0078D4"/>
+            <a:srgbClr val="2E7D32"/>
           </a:solidFill>
           <a:ln w="19050">
             <a:solidFill>
-              <a:srgbClr val="005A9E"/>
+              <a:srgbClr val="1B5E20"/>
             </a:solidFill>
             <a:prstDash val="solid"/>
           </a:ln>
@@ -12059,8 +12366,8 @@
         </p:nvSpPr>
         <p:spPr>
           <a:xfrm>
-            <a:off x="548640" y="1463040"/>
-            <a:ext cx="2377440" cy="914400"/>
+            <a:off x="457200" y="1325880"/>
+            <a:ext cx="1691640" cy="1097280"/>
           </a:xfrm>
           <a:prstGeom prst="rect">
             <a:avLst/>
@@ -12076,49 +12383,49 @@
               <a:buNone/>
             </a:pPr>
             <a:r>
-              <a:rPr lang="en-US" sz="1000" dirty="0">
-                <a:solidFill>
-                  <a:srgbClr val="FFFFFF"/>
-                </a:solidFill>
-                <a:latin typeface="Calibri" pitchFamily="34" charset="0"/>
-                <a:ea typeface="Calibri" pitchFamily="34" charset="-122"/>
-                <a:cs typeface="Calibri" pitchFamily="34" charset="-120"/>
-              </a:rPr>
-              <a:t>Detección</a:t>
-            </a:r>
-            <a:endParaRPr lang="en-US" sz="1000" dirty="0"/>
-          </a:p>
-          <a:p>
-            <a:pPr algn="ctr" indent="0" marL="0">
-              <a:buNone/>
-            </a:pPr>
-            <a:r>
-              <a:rPr lang="en-US" sz="1000" dirty="0">
-                <a:solidFill>
-                  <a:srgbClr val="FFFFFF"/>
-                </a:solidFill>
-                <a:latin typeface="Calibri" pitchFamily="34" charset="0"/>
-                <a:ea typeface="Calibri" pitchFamily="34" charset="-122"/>
-                <a:cs typeface="Calibri" pitchFamily="34" charset="-120"/>
-              </a:rPr>
-              <a:t>Lead u origen</a:t>
-            </a:r>
-            <a:endParaRPr lang="en-US" sz="1000" dirty="0"/>
-          </a:p>
-          <a:p>
-            <a:pPr algn="ctr" indent="0" marL="0">
-              <a:buNone/>
-            </a:pPr>
-            <a:r>
-              <a:rPr lang="en-US" sz="1000" dirty="0">
-                <a:solidFill>
-                  <a:srgbClr val="FFFFFF"/>
-                </a:solidFill>
-                <a:latin typeface="Calibri" pitchFamily="34" charset="0"/>
-                <a:ea typeface="Calibri" pitchFamily="34" charset="-122"/>
-                <a:cs typeface="Calibri" pitchFamily="34" charset="-120"/>
-              </a:rPr>
-              <a:t>comercial</a:t>
+              <a:rPr lang="en-US" sz="1000" b="1" dirty="0">
+                <a:solidFill>
+                  <a:srgbClr val="FFFFFF"/>
+                </a:solidFill>
+                <a:latin typeface="Calibri" pitchFamily="34" charset="0"/>
+                <a:ea typeface="Calibri" pitchFamily="34" charset="-122"/>
+                <a:cs typeface="Calibri" pitchFamily="34" charset="-120"/>
+              </a:rPr>
+              <a:t>Match</a:t>
+            </a:r>
+            <a:endParaRPr lang="en-US" sz="1000" dirty="0"/>
+          </a:p>
+          <a:p>
+            <a:pPr algn="ctr" indent="0" marL="0">
+              <a:buNone/>
+            </a:pPr>
+            <a:r>
+              <a:rPr lang="en-US" sz="1000" b="1" dirty="0">
+                <a:solidFill>
+                  <a:srgbClr val="FFFFFF"/>
+                </a:solidFill>
+                <a:latin typeface="Calibri" pitchFamily="34" charset="0"/>
+                <a:ea typeface="Calibri" pitchFamily="34" charset="-122"/>
+                <a:cs typeface="Calibri" pitchFamily="34" charset="-120"/>
+              </a:rPr>
+              <a:t>Oferta ↔</a:t>
+            </a:r>
+            <a:endParaRPr lang="en-US" sz="1000" dirty="0"/>
+          </a:p>
+          <a:p>
+            <a:pPr algn="ctr" indent="0" marL="0">
+              <a:buNone/>
+            </a:pPr>
+            <a:r>
+              <a:rPr lang="en-US" sz="1000" b="1" dirty="0">
+                <a:solidFill>
+                  <a:srgbClr val="FFFFFF"/>
+                </a:solidFill>
+                <a:latin typeface="Calibri" pitchFamily="34" charset="0"/>
+                <a:ea typeface="Calibri" pitchFamily="34" charset="-122"/>
+                <a:cs typeface="Calibri" pitchFamily="34" charset="-120"/>
+              </a:rPr>
+              <a:t>Demanda</a:t>
             </a:r>
             <a:endParaRPr lang="en-US" sz="1000" dirty="0"/>
           </a:p>
@@ -12132,7 +12439,7 @@
         </p:nvSpPr>
         <p:spPr>
           <a:xfrm>
-            <a:off x="438912" y="1353312"/>
+            <a:off x="347472" y="1216152"/>
             <a:ext cx="329184" cy="329184"/>
           </a:xfrm>
           <a:prstGeom prst="ellipse">
@@ -12157,7 +12464,7 @@
         </p:nvSpPr>
         <p:spPr>
           <a:xfrm>
-            <a:off x="438912" y="1353312"/>
+            <a:off x="347472" y="1216152"/>
             <a:ext cx="329184" cy="329184"/>
           </a:xfrm>
           <a:prstGeom prst="rect">
@@ -12196,20 +12503,20 @@
         </p:nvSpPr>
         <p:spPr>
           <a:xfrm>
-            <a:off x="3200400" y="1463040"/>
-            <a:ext cx="2377440" cy="914400"/>
+            <a:off x="2423160" y="1325880"/>
+            <a:ext cx="1691640" cy="1097280"/>
           </a:xfrm>
           <a:prstGeom prst="roundRect">
             <a:avLst>
-              <a:gd name="adj" fmla="val 8000"/>
+              <a:gd name="adj" fmla="val 6667"/>
             </a:avLst>
           </a:prstGeom>
           <a:solidFill>
-            <a:srgbClr val="0078D4"/>
+            <a:srgbClr val="2E7D32"/>
           </a:solidFill>
           <a:ln w="19050">
             <a:solidFill>
-              <a:srgbClr val="005A9E"/>
+              <a:srgbClr val="1B5E20"/>
             </a:solidFill>
             <a:prstDash val="solid"/>
           </a:ln>
@@ -12230,8 +12537,8 @@
         </p:nvSpPr>
         <p:spPr>
           <a:xfrm>
-            <a:off x="3200400" y="1463040"/>
-            <a:ext cx="2377440" cy="914400"/>
+            <a:off x="2423160" y="1325880"/>
+            <a:ext cx="1691640" cy="1097280"/>
           </a:xfrm>
           <a:prstGeom prst="rect">
             <a:avLst/>
@@ -12255,7 +12562,7 @@
                 <a:ea typeface="Calibri" pitchFamily="34" charset="-122"/>
                 <a:cs typeface="Calibri" pitchFamily="34" charset="-120"/>
               </a:rPr>
-              <a:t>Cualificación</a:t>
+              <a:t>Click</a:t>
             </a:r>
             <a:endParaRPr lang="en-US" sz="1000" dirty="0"/>
           </a:p>
@@ -12272,7 +12579,24 @@
                 <a:ea typeface="Calibri" pitchFamily="34" charset="-122"/>
                 <a:cs typeface="Calibri" pitchFamily="34" charset="-120"/>
               </a:rPr>
-              <a:t>BANT + score</a:t>
+              <a:t>Transformar</a:t>
+            </a:r>
+            <a:endParaRPr lang="en-US" sz="1000" dirty="0"/>
+          </a:p>
+          <a:p>
+            <a:pPr algn="ctr" indent="0" marL="0">
+              <a:buNone/>
+            </a:pPr>
+            <a:r>
+              <a:rPr lang="en-US" sz="1000" dirty="0">
+                <a:solidFill>
+                  <a:srgbClr val="FFFFFF"/>
+                </a:solidFill>
+                <a:latin typeface="Calibri" pitchFamily="34" charset="0"/>
+                <a:ea typeface="Calibri" pitchFamily="34" charset="-122"/>
+                <a:cs typeface="Calibri" pitchFamily="34" charset="-120"/>
+              </a:rPr>
+              <a:t>en Oportunidad</a:t>
             </a:r>
             <a:endParaRPr lang="en-US" sz="1000" dirty="0"/>
           </a:p>
@@ -12286,7 +12610,7 @@
         </p:nvSpPr>
         <p:spPr>
           <a:xfrm>
-            <a:off x="3090672" y="1353312"/>
+            <a:off x="2313432" y="1216152"/>
             <a:ext cx="329184" cy="329184"/>
           </a:xfrm>
           <a:prstGeom prst="ellipse">
@@ -12311,7 +12635,7 @@
         </p:nvSpPr>
         <p:spPr>
           <a:xfrm>
-            <a:off x="3090672" y="1353312"/>
+            <a:off x="2313432" y="1216152"/>
             <a:ext cx="329184" cy="329184"/>
           </a:xfrm>
           <a:prstGeom prst="rect">
@@ -12350,12 +12674,12 @@
         </p:nvSpPr>
         <p:spPr>
           <a:xfrm>
-            <a:off x="6309360" y="1463040"/>
-            <a:ext cx="1691640" cy="914400"/>
+            <a:off x="6812280" y="1325880"/>
+            <a:ext cx="1691640" cy="1097280"/>
           </a:xfrm>
           <a:prstGeom prst="roundRect">
             <a:avLst>
-              <a:gd name="adj" fmla="val 8000"/>
+              <a:gd name="adj" fmla="val 6667"/>
             </a:avLst>
           </a:prstGeom>
           <a:solidFill>
@@ -12384,8 +12708,8 @@
         </p:nvSpPr>
         <p:spPr>
           <a:xfrm>
-            <a:off x="6309360" y="1463040"/>
-            <a:ext cx="1691640" cy="914400"/>
+            <a:off x="6812280" y="1325880"/>
+            <a:ext cx="1691640" cy="1097280"/>
           </a:xfrm>
           <a:prstGeom prst="rect">
             <a:avLst/>
@@ -12409,7 +12733,7 @@
                 <a:ea typeface="Calibri" pitchFamily="34" charset="-122"/>
                 <a:cs typeface="Calibri" pitchFamily="34" charset="-120"/>
               </a:rPr>
-              <a:t>Conversión</a:t>
+              <a:t>Sync vuelta</a:t>
             </a:r>
             <a:endParaRPr lang="en-US" sz="1000" dirty="0"/>
           </a:p>
@@ -12426,7 +12750,7 @@
                 <a:ea typeface="Calibri" pitchFamily="34" charset="-122"/>
                 <a:cs typeface="Calibri" pitchFamily="34" charset="-120"/>
               </a:rPr>
-              <a:t>a Demanda</a:t>
+              <a:t>WIP visible</a:t>
             </a:r>
             <a:endParaRPr lang="en-US" sz="1000" dirty="0"/>
           </a:p>
@@ -12443,7 +12767,7 @@
                 <a:ea typeface="Calibri" pitchFamily="34" charset="-122"/>
                 <a:cs typeface="Calibri" pitchFamily="34" charset="-120"/>
               </a:rPr>
-              <a:t>en PDB</a:t>
+              <a:t>en lectura</a:t>
             </a:r>
             <a:endParaRPr lang="en-US" sz="1000" dirty="0"/>
           </a:p>
@@ -12457,7 +12781,7 @@
         </p:nvSpPr>
         <p:spPr>
           <a:xfrm>
-            <a:off x="6199632" y="1353312"/>
+            <a:off x="6702552" y="1216152"/>
             <a:ext cx="329184" cy="329184"/>
           </a:xfrm>
           <a:prstGeom prst="ellipse">
@@ -12482,7 +12806,7 @@
         </p:nvSpPr>
         <p:spPr>
           <a:xfrm>
-            <a:off x="6199632" y="1353312"/>
+            <a:off x="6702552" y="1216152"/>
             <a:ext cx="329184" cy="329184"/>
           </a:xfrm>
           <a:prstGeom prst="rect">
@@ -12507,7 +12831,7 @@
                 <a:ea typeface="Calibri" pitchFamily="34" charset="-122"/>
                 <a:cs typeface="Calibri" pitchFamily="34" charset="-120"/>
               </a:rPr>
-              <a:t>3</a:t>
+              <a:t>5</a:t>
             </a:r>
             <a:endParaRPr lang="en-US" sz="1000" dirty="0"/>
           </a:p>
@@ -12521,12 +12845,12 @@
         </p:nvSpPr>
         <p:spPr>
           <a:xfrm>
-            <a:off x="8229600" y="1463040"/>
-            <a:ext cx="1691640" cy="914400"/>
+            <a:off x="8686800" y="1325880"/>
+            <a:ext cx="1691640" cy="1097280"/>
           </a:xfrm>
           <a:prstGeom prst="roundRect">
             <a:avLst>
-              <a:gd name="adj" fmla="val 8000"/>
+              <a:gd name="adj" fmla="val 6667"/>
             </a:avLst>
           </a:prstGeom>
           <a:solidFill>
@@ -12555,8 +12879,8 @@
         </p:nvSpPr>
         <p:spPr>
           <a:xfrm>
-            <a:off x="8229600" y="1463040"/>
-            <a:ext cx="1691640" cy="914400"/>
+            <a:off x="8686800" y="1325880"/>
+            <a:ext cx="1691640" cy="1097280"/>
           </a:xfrm>
           <a:prstGeom prst="rect">
             <a:avLst/>
@@ -12597,7 +12921,7 @@
                 <a:ea typeface="Calibri" pitchFamily="34" charset="-122"/>
                 <a:cs typeface="Calibri" pitchFamily="34" charset="-120"/>
               </a:rPr>
-              <a:t>Actividades</a:t>
+              <a:t>WIP</a:t>
             </a:r>
             <a:endParaRPr lang="en-US" sz="1000" dirty="0"/>
           </a:p>
@@ -12614,6 +12938,23 @@
                 <a:ea typeface="Calibri" pitchFamily="34" charset="-122"/>
                 <a:cs typeface="Calibri" pitchFamily="34" charset="-120"/>
               </a:rPr>
+              <a:t>actividades</a:t>
+            </a:r>
+            <a:endParaRPr lang="en-US" sz="1000" dirty="0"/>
+          </a:p>
+          <a:p>
+            <a:pPr algn="ctr" indent="0" marL="0">
+              <a:buNone/>
+            </a:pPr>
+            <a:r>
+              <a:rPr lang="en-US" sz="1000" dirty="0">
+                <a:solidFill>
+                  <a:srgbClr val="FFFFFF"/>
+                </a:solidFill>
+                <a:latin typeface="Calibri" pitchFamily="34" charset="0"/>
+                <a:ea typeface="Calibri" pitchFamily="34" charset="-122"/>
+                <a:cs typeface="Calibri" pitchFamily="34" charset="-120"/>
+              </a:rPr>
               <a:t>+ visitas</a:t>
             </a:r>
             <a:endParaRPr lang="en-US" sz="1000" dirty="0"/>
@@ -12628,7 +12969,7 @@
         </p:nvSpPr>
         <p:spPr>
           <a:xfrm>
-            <a:off x="8119872" y="1353312"/>
+            <a:off x="8577072" y="1216152"/>
             <a:ext cx="329184" cy="329184"/>
           </a:xfrm>
           <a:prstGeom prst="ellipse">
@@ -12653,7 +12994,7 @@
         </p:nvSpPr>
         <p:spPr>
           <a:xfrm>
-            <a:off x="8119872" y="1353312"/>
+            <a:off x="8577072" y="1216152"/>
             <a:ext cx="329184" cy="329184"/>
           </a:xfrm>
           <a:prstGeom prst="rect">
@@ -12678,7 +13019,7 @@
                 <a:ea typeface="Calibri" pitchFamily="34" charset="-122"/>
                 <a:cs typeface="Calibri" pitchFamily="34" charset="-120"/>
               </a:rPr>
-              <a:t>4</a:t>
+              <a:t>6</a:t>
             </a:r>
             <a:endParaRPr lang="en-US" sz="1000" dirty="0"/>
           </a:p>
@@ -12692,12 +13033,12 @@
         </p:nvSpPr>
         <p:spPr>
           <a:xfrm>
-            <a:off x="10149840" y="1463040"/>
-            <a:ext cx="1691640" cy="914400"/>
+            <a:off x="10561320" y="1325880"/>
+            <a:ext cx="1280160" cy="1097280"/>
           </a:xfrm>
           <a:prstGeom prst="roundRect">
             <a:avLst>
-              <a:gd name="adj" fmla="val 8000"/>
+              <a:gd name="adj" fmla="val 6667"/>
             </a:avLst>
           </a:prstGeom>
           <a:solidFill>
@@ -12726,8 +13067,8 @@
         </p:nvSpPr>
         <p:spPr>
           <a:xfrm>
-            <a:off x="10149840" y="1463040"/>
-            <a:ext cx="1691640" cy="914400"/>
+            <a:off x="10561320" y="1325880"/>
+            <a:ext cx="1280160" cy="1097280"/>
           </a:xfrm>
           <a:prstGeom prst="rect">
             <a:avLst/>
@@ -12751,27 +13092,27 @@
                 <a:ea typeface="Calibri" pitchFamily="34" charset="-122"/>
                 <a:cs typeface="Calibri" pitchFamily="34" charset="-120"/>
               </a:rPr>
+              <a:t>Avanza a</a:t>
+            </a:r>
+            <a:endParaRPr lang="en-US" sz="1000" dirty="0"/>
+          </a:p>
+          <a:p>
+            <a:pPr algn="ctr" indent="0" marL="0">
+              <a:buNone/>
+            </a:pPr>
+            <a:r>
+              <a:rPr lang="en-US" sz="1000" dirty="0">
+                <a:solidFill>
+                  <a:srgbClr val="FFFFFF"/>
+                </a:solidFill>
+                <a:latin typeface="Calibri" pitchFamily="34" charset="0"/>
+                <a:ea typeface="Calibri" pitchFamily="34" charset="-122"/>
+                <a:cs typeface="Calibri" pitchFamily="34" charset="-120"/>
+              </a:rPr>
               <a:t>Negociación</a:t>
             </a:r>
             <a:endParaRPr lang="en-US" sz="1000" dirty="0"/>
           </a:p>
-          <a:p>
-            <a:pPr algn="ctr" indent="0" marL="0">
-              <a:buNone/>
-            </a:pPr>
-            <a:r>
-              <a:rPr lang="en-US" sz="1000" dirty="0">
-                <a:solidFill>
-                  <a:srgbClr val="FFFFFF"/>
-                </a:solidFill>
-                <a:latin typeface="Calibri" pitchFamily="34" charset="0"/>
-                <a:ea typeface="Calibri" pitchFamily="34" charset="-122"/>
-                <a:cs typeface="Calibri" pitchFamily="34" charset="-120"/>
-              </a:rPr>
-              <a:t>Oferta viva</a:t>
-            </a:r>
-            <a:endParaRPr lang="en-US" sz="1000" dirty="0"/>
-          </a:p>
         </p:txBody>
       </p:sp>
       <p:sp>
@@ -12782,7 +13123,7 @@
         </p:nvSpPr>
         <p:spPr>
           <a:xfrm>
-            <a:off x="10040112" y="1353312"/>
+            <a:off x="10451592" y="1216152"/>
             <a:ext cx="329184" cy="329184"/>
           </a:xfrm>
           <a:prstGeom prst="ellipse">
@@ -12807,7 +13148,7 @@
         </p:nvSpPr>
         <p:spPr>
           <a:xfrm>
-            <a:off x="10040112" y="1353312"/>
+            <a:off x="10451592" y="1216152"/>
             <a:ext cx="329184" cy="329184"/>
           </a:xfrm>
           <a:prstGeom prst="rect">
@@ -12832,7 +13173,7 @@
                 <a:ea typeface="Calibri" pitchFamily="34" charset="-122"/>
                 <a:cs typeface="Calibri" pitchFamily="34" charset="-120"/>
               </a:rPr>
-              <a:t>5</a:t>
+              <a:t>7a</a:t>
             </a:r>
             <a:endParaRPr lang="en-US" sz="1000" dirty="0"/>
           </a:p>
@@ -12846,20 +13187,20 @@
         </p:nvSpPr>
         <p:spPr>
           <a:xfrm>
-            <a:off x="1371600" y="4023360"/>
-            <a:ext cx="2194560" cy="1097280"/>
+            <a:off x="2743200" y="3657600"/>
+            <a:ext cx="1783080" cy="1371600"/>
           </a:xfrm>
           <a:prstGeom prst="roundRect">
             <a:avLst>
-              <a:gd name="adj" fmla="val 6667"/>
+              <a:gd name="adj" fmla="val 5333"/>
             </a:avLst>
           </a:prstGeom>
           <a:solidFill>
-            <a:srgbClr val="7C3AED"/>
+            <a:srgbClr val="0078D4"/>
           </a:solidFill>
           <a:ln w="19050">
             <a:solidFill>
-              <a:srgbClr val="5B21B6"/>
+              <a:srgbClr val="005A9E"/>
             </a:solidFill>
             <a:prstDash val="solid"/>
           </a:ln>
@@ -12880,8 +13221,8 @@
         </p:nvSpPr>
         <p:spPr>
           <a:xfrm>
-            <a:off x="1371600" y="4023360"/>
-            <a:ext cx="2194560" cy="1097280"/>
+            <a:off x="2743200" y="3657600"/>
+            <a:ext cx="1783080" cy="1371600"/>
           </a:xfrm>
           <a:prstGeom prst="rect">
             <a:avLst/>
@@ -12897,34 +13238,68 @@
               <a:buNone/>
             </a:pPr>
             <a:r>
-              <a:rPr lang="en-US" sz="1100" dirty="0">
-                <a:solidFill>
-                  <a:srgbClr val="FFFFFF"/>
-                </a:solidFill>
-                <a:latin typeface="Calibri" pitchFamily="34" charset="0"/>
-                <a:ea typeface="Calibri" pitchFamily="34" charset="-122"/>
-                <a:cs typeface="Calibri" pitchFamily="34" charset="-120"/>
-              </a:rPr>
-              <a:t>Cierre Ganada</a:t>
-            </a:r>
-            <a:endParaRPr lang="en-US" sz="1100" dirty="0"/>
-          </a:p>
-          <a:p>
-            <a:pPr algn="ctr" indent="0" marL="0">
-              <a:buNone/>
-            </a:pPr>
-            <a:r>
-              <a:rPr lang="en-US" sz="1100" dirty="0">
-                <a:solidFill>
-                  <a:srgbClr val="FFFFFF"/>
-                </a:solidFill>
-                <a:latin typeface="Calibri" pitchFamily="34" charset="0"/>
-                <a:ea typeface="Calibri" pitchFamily="34" charset="-122"/>
-                <a:cs typeface="Calibri" pitchFamily="34" charset="-120"/>
-              </a:rPr>
-              <a:t>→ Transacción</a:t>
-            </a:r>
-            <a:endParaRPr lang="en-US" sz="1100" dirty="0"/>
+              <a:rPr lang="en-US" sz="1000" dirty="0">
+                <a:solidFill>
+                  <a:srgbClr val="FFFFFF"/>
+                </a:solidFill>
+                <a:latin typeface="Calibri" pitchFamily="34" charset="0"/>
+                <a:ea typeface="Calibri" pitchFamily="34" charset="-122"/>
+                <a:cs typeface="Calibri" pitchFamily="34" charset="-120"/>
+              </a:rPr>
+              <a:t>Apertura</a:t>
+            </a:r>
+            <a:endParaRPr lang="en-US" sz="1000" dirty="0"/>
+          </a:p>
+          <a:p>
+            <a:pPr algn="ctr" indent="0" marL="0">
+              <a:buNone/>
+            </a:pPr>
+            <a:r>
+              <a:rPr lang="en-US" sz="1000" dirty="0">
+                <a:solidFill>
+                  <a:srgbClr val="FFFFFF"/>
+                </a:solidFill>
+                <a:latin typeface="Calibri" pitchFamily="34" charset="0"/>
+                <a:ea typeface="Calibri" pitchFamily="34" charset="-122"/>
+                <a:cs typeface="Calibri" pitchFamily="34" charset="-120"/>
+              </a:rPr>
+              <a:t>Dynamics</a:t>
+            </a:r>
+            <a:endParaRPr lang="en-US" sz="1000" dirty="0"/>
+          </a:p>
+          <a:p>
+            <a:pPr algn="ctr" indent="0" marL="0">
+              <a:buNone/>
+            </a:pPr>
+            <a:r>
+              <a:rPr lang="en-US" sz="1000" dirty="0">
+                <a:solidFill>
+                  <a:srgbClr val="FFFFFF"/>
+                </a:solidFill>
+                <a:latin typeface="Calibri" pitchFamily="34" charset="0"/>
+                <a:ea typeface="Calibri" pitchFamily="34" charset="-122"/>
+                <a:cs typeface="Calibri" pitchFamily="34" charset="-120"/>
+              </a:rPr>
+              <a:t>datos</a:t>
+            </a:r>
+            <a:endParaRPr lang="en-US" sz="1000" dirty="0"/>
+          </a:p>
+          <a:p>
+            <a:pPr algn="ctr" indent="0" marL="0">
+              <a:buNone/>
+            </a:pPr>
+            <a:r>
+              <a:rPr lang="en-US" sz="1000" dirty="0">
+                <a:solidFill>
+                  <a:srgbClr val="FFFFFF"/>
+                </a:solidFill>
+                <a:latin typeface="Calibri" pitchFamily="34" charset="0"/>
+                <a:ea typeface="Calibri" pitchFamily="34" charset="-122"/>
+                <a:cs typeface="Calibri" pitchFamily="34" charset="-120"/>
+              </a:rPr>
+              <a:t>preasignados</a:t>
+            </a:r>
+            <a:endParaRPr lang="en-US" sz="1000" dirty="0"/>
           </a:p>
         </p:txBody>
       </p:sp>
@@ -12936,7 +13311,7 @@
         </p:nvSpPr>
         <p:spPr>
           <a:xfrm>
-            <a:off x="1261872" y="3913632"/>
+            <a:off x="2633472" y="3547872"/>
             <a:ext cx="329184" cy="329184"/>
           </a:xfrm>
           <a:prstGeom prst="ellipse">
@@ -12961,7 +13336,7 @@
         </p:nvSpPr>
         <p:spPr>
           <a:xfrm>
-            <a:off x="1261872" y="3913632"/>
+            <a:off x="2633472" y="3547872"/>
             <a:ext cx="329184" cy="329184"/>
           </a:xfrm>
           <a:prstGeom prst="rect">
@@ -12986,7 +13361,7 @@
                 <a:ea typeface="Calibri" pitchFamily="34" charset="-122"/>
                 <a:cs typeface="Calibri" pitchFamily="34" charset="-120"/>
               </a:rPr>
-              <a:t>6a</a:t>
+              <a:t>3</a:t>
             </a:r>
             <a:endParaRPr lang="en-US" sz="1000" dirty="0"/>
           </a:p>
@@ -13000,20 +13375,20 @@
         </p:nvSpPr>
         <p:spPr>
           <a:xfrm>
-            <a:off x="3840480" y="4023360"/>
-            <a:ext cx="2194560" cy="1097280"/>
+            <a:off x="4709160" y="3657600"/>
+            <a:ext cx="1783080" cy="1371600"/>
           </a:xfrm>
           <a:prstGeom prst="roundRect">
             <a:avLst>
-              <a:gd name="adj" fmla="val 6667"/>
+              <a:gd name="adj" fmla="val 5333"/>
             </a:avLst>
           </a:prstGeom>
           <a:solidFill>
-            <a:srgbClr val="DC2626"/>
-          </a:solidFill>
-          <a:ln w="31750">
-            <a:solidFill>
-              <a:srgbClr val="991B1B"/>
+            <a:srgbClr val="0078D4"/>
+          </a:solidFill>
+          <a:ln w="19050">
+            <a:solidFill>
+              <a:srgbClr val="005A9E"/>
             </a:solidFill>
             <a:prstDash val="solid"/>
           </a:ln>
@@ -13034,8 +13409,8 @@
         </p:nvSpPr>
         <p:spPr>
           <a:xfrm>
-            <a:off x="3840480" y="4023360"/>
-            <a:ext cx="2194560" cy="1097280"/>
+            <a:off x="4709160" y="3657600"/>
+            <a:ext cx="1783080" cy="1371600"/>
           </a:xfrm>
           <a:prstGeom prst="rect">
             <a:avLst/>
@@ -13051,7 +13426,195 @@
               <a:buNone/>
             </a:pPr>
             <a:r>
-              <a:rPr lang="en-US" sz="1100" dirty="0">
+              <a:rPr lang="en-US" sz="1000" b="1" dirty="0">
+                <a:solidFill>
+                  <a:srgbClr val="FFFFFF"/>
+                </a:solidFill>
+                <a:latin typeface="Calibri" pitchFamily="34" charset="0"/>
+                <a:ea typeface="Calibri" pitchFamily="34" charset="-122"/>
+                <a:cs typeface="Calibri" pitchFamily="34" charset="-120"/>
+              </a:rPr>
+              <a:t>Creación</a:t>
+            </a:r>
+            <a:endParaRPr lang="en-US" sz="1000" dirty="0"/>
+          </a:p>
+          <a:p>
+            <a:pPr algn="ctr" indent="0" marL="0">
+              <a:buNone/>
+            </a:pPr>
+            <a:r>
+              <a:rPr lang="en-US" sz="1000" b="1" dirty="0">
+                <a:solidFill>
+                  <a:srgbClr val="FFFFFF"/>
+                </a:solidFill>
+                <a:latin typeface="Calibri" pitchFamily="34" charset="0"/>
+                <a:ea typeface="Calibri" pitchFamily="34" charset="-122"/>
+                <a:cs typeface="Calibri" pitchFamily="34" charset="-120"/>
+              </a:rPr>
+              <a:t>Oportunidad</a:t>
+            </a:r>
+            <a:endParaRPr lang="en-US" sz="1000" dirty="0"/>
+          </a:p>
+          <a:p>
+            <a:pPr algn="ctr" indent="0" marL="0">
+              <a:buNone/>
+            </a:pPr>
+            <a:r>
+              <a:rPr lang="en-US" sz="1000" b="1" dirty="0">
+                <a:solidFill>
+                  <a:srgbClr val="FFFFFF"/>
+                </a:solidFill>
+                <a:latin typeface="Calibri" pitchFamily="34" charset="0"/>
+                <a:ea typeface="Calibri" pitchFamily="34" charset="-122"/>
+                <a:cs typeface="Calibri" pitchFamily="34" charset="-120"/>
+              </a:rPr>
+              <a:t>registro</a:t>
+            </a:r>
+            <a:endParaRPr lang="en-US" sz="1000" dirty="0"/>
+          </a:p>
+          <a:p>
+            <a:pPr algn="ctr" indent="0" marL="0">
+              <a:buNone/>
+            </a:pPr>
+            <a:r>
+              <a:rPr lang="en-US" sz="1000" b="1" dirty="0">
+                <a:solidFill>
+                  <a:srgbClr val="FFFFFF"/>
+                </a:solidFill>
+                <a:latin typeface="Calibri" pitchFamily="34" charset="0"/>
+                <a:ea typeface="Calibri" pitchFamily="34" charset="-122"/>
+                <a:cs typeface="Calibri" pitchFamily="34" charset="-120"/>
+              </a:rPr>
+              <a:t>maestro WIP</a:t>
+            </a:r>
+            <a:endParaRPr lang="en-US" sz="1000" dirty="0"/>
+          </a:p>
+        </p:txBody>
+      </p:sp>
+      <p:sp>
+        <p:nvSpPr>
+          <p:cNvPr id="41" name="Shape 39"/>
+          <p:cNvSpPr/>
+          <p:nvPr/>
+        </p:nvSpPr>
+        <p:spPr>
+          <a:xfrm>
+            <a:off x="4599432" y="3547872"/>
+            <a:ext cx="329184" cy="329184"/>
+          </a:xfrm>
+          <a:prstGeom prst="ellipse">
+            <a:avLst/>
+          </a:prstGeom>
+          <a:solidFill>
+            <a:srgbClr val="1A237E"/>
+          </a:solidFill>
+          <a:ln w="25400">
+            <a:solidFill>
+              <a:srgbClr val="FFFFFF"/>
+            </a:solidFill>
+            <a:prstDash val="solid"/>
+          </a:ln>
+        </p:spPr>
+      </p:sp>
+      <p:sp>
+        <p:nvSpPr>
+          <p:cNvPr id="42" name="Text 40"/>
+          <p:cNvSpPr/>
+          <p:nvPr/>
+        </p:nvSpPr>
+        <p:spPr>
+          <a:xfrm>
+            <a:off x="4599432" y="3547872"/>
+            <a:ext cx="329184" cy="329184"/>
+          </a:xfrm>
+          <a:prstGeom prst="rect">
+            <a:avLst/>
+          </a:prstGeom>
+          <a:noFill/>
+          <a:ln/>
+        </p:spPr>
+        <p:txBody>
+          <a:bodyPr wrap="square" rtlCol="0" anchor="ctr"/>
+          <a:lstStyle/>
+          <a:p>
+            <a:pPr algn="ctr" indent="0" marL="0">
+              <a:buNone/>
+            </a:pPr>
+            <a:r>
+              <a:rPr lang="en-US" sz="1000" b="1" dirty="0">
+                <a:solidFill>
+                  <a:srgbClr val="FFFFFF"/>
+                </a:solidFill>
+                <a:latin typeface="Calibri" pitchFamily="34" charset="0"/>
+                <a:ea typeface="Calibri" pitchFamily="34" charset="-122"/>
+                <a:cs typeface="Calibri" pitchFamily="34" charset="-120"/>
+              </a:rPr>
+              <a:t>4</a:t>
+            </a:r>
+            <a:endParaRPr lang="en-US" sz="1000" dirty="0"/>
+          </a:p>
+        </p:txBody>
+      </p:sp>
+      <p:sp>
+        <p:nvSpPr>
+          <p:cNvPr id="43" name="Shape 41"/>
+          <p:cNvSpPr/>
+          <p:nvPr/>
+        </p:nvSpPr>
+        <p:spPr>
+          <a:xfrm>
+            <a:off x="8686800" y="3657600"/>
+            <a:ext cx="1783080" cy="1371600"/>
+          </a:xfrm>
+          <a:prstGeom prst="roundRect">
+            <a:avLst>
+              <a:gd name="adj" fmla="val 5333"/>
+            </a:avLst>
+          </a:prstGeom>
+          <a:solidFill>
+            <a:srgbClr val="DC2626"/>
+          </a:solidFill>
+          <a:ln w="31750">
+            <a:solidFill>
+              <a:srgbClr val="991B1B"/>
+            </a:solidFill>
+            <a:prstDash val="solid"/>
+          </a:ln>
+          <a:effectLst>
+            <a:outerShdw sx="100000" sy="100000" kx="0" ky="0" algn="bl" rotWithShape="0" blurRad="50800" dist="25400" dir="2700000">
+              <a:srgbClr val="00000022">
+                <a:alpha val="75000"/>
+              </a:srgbClr>
+            </a:outerShdw>
+          </a:effectLst>
+        </p:spPr>
+      </p:sp>
+      <p:sp>
+        <p:nvSpPr>
+          <p:cNvPr id="44" name="Text 42"/>
+          <p:cNvSpPr/>
+          <p:nvPr/>
+        </p:nvSpPr>
+        <p:spPr>
+          <a:xfrm>
+            <a:off x="8686800" y="3657600"/>
+            <a:ext cx="1783080" cy="1371600"/>
+          </a:xfrm>
+          <a:prstGeom prst="rect">
+            <a:avLst/>
+          </a:prstGeom>
+          <a:noFill/>
+          <a:ln/>
+        </p:spPr>
+        <p:txBody>
+          <a:bodyPr wrap="square" rtlCol="0" anchor="ctr"/>
+          <a:lstStyle/>
+          <a:p>
+            <a:pPr algn="ctr" indent="0" marL="0">
+              <a:buNone/>
+            </a:pPr>
+            <a:r>
+              <a:rPr lang="en-US" sz="1000" dirty="0">
                 <a:solidFill>
                   <a:srgbClr val="FFFFFF"/>
                 </a:solidFill>
@@ -13061,31 +13624,31 @@
               </a:rPr>
               <a:t>Cierre Perdida</a:t>
             </a:r>
-            <a:endParaRPr lang="en-US" sz="1100" dirty="0"/>
-          </a:p>
-          <a:p>
-            <a:pPr algn="ctr" indent="0" marL="0">
-              <a:buNone/>
-            </a:pPr>
-            <a:r>
-              <a:rPr lang="en-US" sz="1100" dirty="0">
-                <a:solidFill>
-                  <a:srgbClr val="FFFFFF"/>
-                </a:solidFill>
-                <a:latin typeface="Calibri" pitchFamily="34" charset="0"/>
-                <a:ea typeface="Calibri" pitchFamily="34" charset="-122"/>
-                <a:cs typeface="Calibri" pitchFamily="34" charset="-120"/>
-              </a:rPr>
-              <a:t>Motivo +</a:t>
-            </a:r>
-            <a:endParaRPr lang="en-US" sz="1100" dirty="0"/>
-          </a:p>
-          <a:p>
-            <a:pPr algn="ctr" indent="0" marL="0">
-              <a:buNone/>
-            </a:pPr>
-            <a:r>
-              <a:rPr lang="en-US" sz="1100" dirty="0">
+            <a:endParaRPr lang="en-US" sz="1000" dirty="0"/>
+          </a:p>
+          <a:p>
+            <a:pPr algn="ctr" indent="0" marL="0">
+              <a:buNone/>
+            </a:pPr>
+            <a:r>
+              <a:rPr lang="en-US" sz="1000" dirty="0">
+                <a:solidFill>
+                  <a:srgbClr val="FFFFFF"/>
+                </a:solidFill>
+                <a:latin typeface="Calibri" pitchFamily="34" charset="0"/>
+                <a:ea typeface="Calibri" pitchFamily="34" charset="-122"/>
+                <a:cs typeface="Calibri" pitchFamily="34" charset="-120"/>
+              </a:rPr>
+              <a:t>motivo +</a:t>
+            </a:r>
+            <a:endParaRPr lang="en-US" sz="1000" dirty="0"/>
+          </a:p>
+          <a:p>
+            <a:pPr algn="ctr" indent="0" marL="0">
+              <a:buNone/>
+            </a:pPr>
+            <a:r>
+              <a:rPr lang="en-US" sz="1000" dirty="0">
                 <a:solidFill>
                   <a:srgbClr val="FFFFFF"/>
                 </a:solidFill>
@@ -13095,19 +13658,19 @@
               </a:rPr>
               <a:t>lecciones</a:t>
             </a:r>
-            <a:endParaRPr lang="en-US" sz="1100" dirty="0"/>
-          </a:p>
-        </p:txBody>
-      </p:sp>
-      <p:sp>
-        <p:nvSpPr>
-          <p:cNvPr id="41" name="Shape 39"/>
-          <p:cNvSpPr/>
-          <p:nvPr/>
-        </p:nvSpPr>
-        <p:spPr>
-          <a:xfrm>
-            <a:off x="3730752" y="3913632"/>
+            <a:endParaRPr lang="en-US" sz="1000" dirty="0"/>
+          </a:p>
+        </p:txBody>
+      </p:sp>
+      <p:sp>
+        <p:nvSpPr>
+          <p:cNvPr id="45" name="Shape 43"/>
+          <p:cNvSpPr/>
+          <p:nvPr/>
+        </p:nvSpPr>
+        <p:spPr>
+          <a:xfrm>
+            <a:off x="8577072" y="3547872"/>
             <a:ext cx="329184" cy="329184"/>
           </a:xfrm>
           <a:prstGeom prst="ellipse">
@@ -13126,13 +13689,13 @@
       </p:sp>
       <p:sp>
         <p:nvSpPr>
-          <p:cNvPr id="42" name="Text 40"/>
-          <p:cNvSpPr/>
-          <p:nvPr/>
-        </p:nvSpPr>
-        <p:spPr>
-          <a:xfrm>
-            <a:off x="3730752" y="3913632"/>
+          <p:cNvPr id="46" name="Text 44"/>
+          <p:cNvSpPr/>
+          <p:nvPr/>
+        </p:nvSpPr>
+        <p:spPr>
+          <a:xfrm>
+            <a:off x="8577072" y="3547872"/>
             <a:ext cx="329184" cy="329184"/>
           </a:xfrm>
           <a:prstGeom prst="rect">
@@ -13157,21 +13720,21 @@
                 <a:ea typeface="Calibri" pitchFamily="34" charset="-122"/>
                 <a:cs typeface="Calibri" pitchFamily="34" charset="-120"/>
               </a:rPr>
-              <a:t>6b</a:t>
-            </a:r>
-            <a:endParaRPr lang="en-US" sz="1000" dirty="0"/>
-          </a:p>
-        </p:txBody>
-      </p:sp>
-      <p:sp>
-        <p:nvSpPr>
-          <p:cNvPr id="43" name="Shape 41"/>
-          <p:cNvSpPr/>
-          <p:nvPr/>
-        </p:nvSpPr>
-        <p:spPr>
-          <a:xfrm>
-            <a:off x="2926080" y="1920240"/>
+              <a:t>7b</a:t>
+            </a:r>
+            <a:endParaRPr lang="en-US" sz="1000" dirty="0"/>
+          </a:p>
+        </p:txBody>
+      </p:sp>
+      <p:sp>
+        <p:nvSpPr>
+          <p:cNvPr id="47" name="Shape 45"/>
+          <p:cNvSpPr/>
+          <p:nvPr/>
+        </p:nvSpPr>
+        <p:spPr>
+          <a:xfrm>
+            <a:off x="2148840" y="1874520"/>
             <a:ext cx="274320" cy="0"/>
           </a:xfrm>
           <a:prstGeom prst="line">
@@ -13189,14 +13752,14 @@
       </p:sp>
       <p:sp>
         <p:nvSpPr>
-          <p:cNvPr id="44" name="Shape 42"/>
-          <p:cNvSpPr/>
-          <p:nvPr/>
-        </p:nvSpPr>
-        <p:spPr>
-          <a:xfrm>
-            <a:off x="5577840" y="1920240"/>
-            <a:ext cx="731520" cy="0"/>
+          <p:cNvPr id="48" name="Shape 46"/>
+          <p:cNvSpPr/>
+          <p:nvPr/>
+        </p:nvSpPr>
+        <p:spPr>
+          <a:xfrm>
+            <a:off x="3291840" y="2423160"/>
+            <a:ext cx="320040" cy="1234440"/>
           </a:xfrm>
           <a:prstGeom prst="line">
             <a:avLst/>
@@ -13213,13 +13776,13 @@
       </p:sp>
       <p:sp>
         <p:nvSpPr>
-          <p:cNvPr id="45" name="Text 43"/>
-          <p:cNvSpPr/>
-          <p:nvPr/>
-        </p:nvSpPr>
-        <p:spPr>
-          <a:xfrm>
-            <a:off x="5349240" y="1801368"/>
+          <p:cNvPr id="49" name="Text 47"/>
+          <p:cNvSpPr/>
+          <p:nvPr/>
+        </p:nvSpPr>
+        <p:spPr>
+          <a:xfrm>
+            <a:off x="2857500" y="2921508"/>
             <a:ext cx="1188720" cy="237744"/>
           </a:xfrm>
           <a:prstGeom prst="rect">
@@ -13248,7 +13811,7 @@
                 <a:ea typeface="Calibri" pitchFamily="34" charset="-122"/>
                 <a:cs typeface="Calibri" pitchFamily="34" charset="-120"/>
               </a:rPr>
-              <a:t>sync + handoff</a:t>
+              <a:t>abre</a:t>
             </a:r>
             <a:endParaRPr lang="en-US" sz="800" dirty="0"/>
           </a:p>
@@ -13256,14 +13819,14 @@
       </p:sp>
       <p:sp>
         <p:nvSpPr>
-          <p:cNvPr id="46" name="Shape 44"/>
-          <p:cNvSpPr/>
-          <p:nvPr/>
-        </p:nvSpPr>
-        <p:spPr>
-          <a:xfrm>
-            <a:off x="8001000" y="1920240"/>
-            <a:ext cx="228600" cy="0"/>
+          <p:cNvPr id="50" name="Shape 48"/>
+          <p:cNvSpPr/>
+          <p:nvPr/>
+        </p:nvSpPr>
+        <p:spPr>
+          <a:xfrm>
+            <a:off x="4526280" y="4343400"/>
+            <a:ext cx="182880" cy="0"/>
           </a:xfrm>
           <a:prstGeom prst="line">
             <a:avLst/>
@@ -13280,14 +13843,14 @@
       </p:sp>
       <p:sp>
         <p:nvSpPr>
-          <p:cNvPr id="47" name="Shape 45"/>
-          <p:cNvSpPr/>
-          <p:nvPr/>
-        </p:nvSpPr>
-        <p:spPr>
-          <a:xfrm>
-            <a:off x="9921240" y="1920240"/>
-            <a:ext cx="228600" cy="0"/>
+          <p:cNvPr id="51" name="Shape 49"/>
+          <p:cNvSpPr/>
+          <p:nvPr/>
+        </p:nvSpPr>
+        <p:spPr>
+          <a:xfrm>
+            <a:off x="5577840" y="3657600"/>
+            <a:ext cx="2103120" cy="-1234440"/>
           </a:xfrm>
           <a:prstGeom prst="line">
             <a:avLst/>
@@ -13295,7 +13858,7 @@
           <a:noFill/>
           <a:ln w="22860">
             <a:solidFill>
-              <a:srgbClr val="BDBDBD"/>
+              <a:srgbClr val="0078D4"/>
             </a:solidFill>
             <a:prstDash val="solid"/>
             <a:tailEnd type="arrow"/>
@@ -13304,37 +13867,13 @@
       </p:sp>
       <p:sp>
         <p:nvSpPr>
-          <p:cNvPr id="48" name="Shape 46"/>
-          <p:cNvSpPr/>
-          <p:nvPr/>
-        </p:nvSpPr>
-        <p:spPr>
-          <a:xfrm>
-            <a:off x="10515600" y="2377440"/>
-            <a:ext cx="-8046720" cy="1645920"/>
-          </a:xfrm>
-          <a:prstGeom prst="line">
-            <a:avLst/>
-          </a:prstGeom>
-          <a:noFill/>
-          <a:ln w="22860">
-            <a:solidFill>
-              <a:srgbClr val="7C3AED"/>
-            </a:solidFill>
-            <a:prstDash val="solid"/>
-            <a:tailEnd type="arrow"/>
-          </a:ln>
-        </p:spPr>
-      </p:sp>
-      <p:sp>
-        <p:nvSpPr>
-          <p:cNvPr id="49" name="Text 47"/>
-          <p:cNvSpPr/>
-          <p:nvPr/>
-        </p:nvSpPr>
-        <p:spPr>
-          <a:xfrm>
-            <a:off x="5897880" y="3081528"/>
+          <p:cNvPr id="52" name="Text 50"/>
+          <p:cNvSpPr/>
+          <p:nvPr/>
+        </p:nvSpPr>
+        <p:spPr>
+          <a:xfrm>
+            <a:off x="6035040" y="2921508"/>
             <a:ext cx="1188720" cy="237744"/>
           </a:xfrm>
           <a:prstGeom prst="rect">
@@ -13363,7 +13902,7 @@
                 <a:ea typeface="Calibri" pitchFamily="34" charset="-122"/>
                 <a:cs typeface="Calibri" pitchFamily="34" charset="-120"/>
               </a:rPr>
-              <a:t>outcome</a:t>
+              <a:t>sync auto</a:t>
             </a:r>
             <a:endParaRPr lang="en-US" sz="800" dirty="0"/>
           </a:p>
@@ -13371,14 +13910,14 @@
       </p:sp>
       <p:sp>
         <p:nvSpPr>
-          <p:cNvPr id="50" name="Shape 48"/>
-          <p:cNvSpPr/>
-          <p:nvPr/>
-        </p:nvSpPr>
-        <p:spPr>
-          <a:xfrm>
-            <a:off x="10515600" y="2377440"/>
-            <a:ext cx="-5577840" cy="1645920"/>
+          <p:cNvPr id="53" name="Shape 51"/>
+          <p:cNvSpPr/>
+          <p:nvPr/>
+        </p:nvSpPr>
+        <p:spPr>
+          <a:xfrm>
+            <a:off x="8503920" y="1874520"/>
+            <a:ext cx="182880" cy="0"/>
           </a:xfrm>
           <a:prstGeom prst="line">
             <a:avLst/>
@@ -13386,22 +13925,70 @@
           <a:noFill/>
           <a:ln w="22860">
             <a:solidFill>
+              <a:srgbClr val="BDBDBD"/>
+            </a:solidFill>
+            <a:prstDash val="solid"/>
+            <a:tailEnd type="arrow"/>
+          </a:ln>
+        </p:spPr>
+      </p:sp>
+      <p:sp>
+        <p:nvSpPr>
+          <p:cNvPr id="54" name="Shape 52"/>
+          <p:cNvSpPr/>
+          <p:nvPr/>
+        </p:nvSpPr>
+        <p:spPr>
+          <a:xfrm>
+            <a:off x="10378440" y="1874520"/>
+            <a:ext cx="182880" cy="0"/>
+          </a:xfrm>
+          <a:prstGeom prst="line">
+            <a:avLst/>
+          </a:prstGeom>
+          <a:noFill/>
+          <a:ln w="22860">
+            <a:solidFill>
+              <a:srgbClr val="BDBDBD"/>
+            </a:solidFill>
+            <a:prstDash val="solid"/>
+            <a:tailEnd type="arrow"/>
+          </a:ln>
+        </p:spPr>
+      </p:sp>
+      <p:sp>
+        <p:nvSpPr>
+          <p:cNvPr id="55" name="Shape 53"/>
+          <p:cNvSpPr/>
+          <p:nvPr/>
+        </p:nvSpPr>
+        <p:spPr>
+          <a:xfrm>
+            <a:off x="9509760" y="2423160"/>
+            <a:ext cx="0" cy="1234440"/>
+          </a:xfrm>
+          <a:prstGeom prst="line">
+            <a:avLst/>
+          </a:prstGeom>
+          <a:noFill/>
+          <a:ln w="22860">
+            <a:solidFill>
               <a:srgbClr val="DC2626"/>
             </a:solidFill>
-            <a:prstDash val="solid"/>
+            <a:prstDash val="dash"/>
             <a:tailEnd type="arrow"/>
           </a:ln>
         </p:spPr>
       </p:sp>
       <p:sp>
         <p:nvSpPr>
-          <p:cNvPr id="51" name="Text 49"/>
-          <p:cNvSpPr/>
-          <p:nvPr/>
-        </p:nvSpPr>
-        <p:spPr>
-          <a:xfrm>
-            <a:off x="7132320" y="3081528"/>
+          <p:cNvPr id="56" name="Text 54"/>
+          <p:cNvSpPr/>
+          <p:nvPr/>
+        </p:nvSpPr>
+        <p:spPr>
+          <a:xfrm>
+            <a:off x="8915400" y="2921508"/>
             <a:ext cx="1188720" cy="237744"/>
           </a:xfrm>
           <a:prstGeom prst="rect">
@@ -13438,71 +14025,7 @@
       </p:sp>
       <p:sp>
         <p:nvSpPr>
-          <p:cNvPr id="52" name="Shape 50"/>
-          <p:cNvSpPr/>
-          <p:nvPr/>
-        </p:nvSpPr>
-        <p:spPr>
-          <a:xfrm>
-            <a:off x="4389120" y="2377440"/>
-            <a:ext cx="2788920" cy="640080"/>
-          </a:xfrm>
-          <a:prstGeom prst="line">
-            <a:avLst/>
-          </a:prstGeom>
-          <a:noFill/>
-          <a:ln w="15240">
-            <a:solidFill>
-              <a:srgbClr val="888888"/>
-            </a:solidFill>
-            <a:prstDash val="dash"/>
-            <a:headEnd type="arrow"/>
-            <a:tailEnd type="arrow"/>
-          </a:ln>
-        </p:spPr>
-      </p:sp>
-      <p:sp>
-        <p:nvSpPr>
-          <p:cNvPr id="53" name="Text 51"/>
-          <p:cNvSpPr/>
-          <p:nvPr/>
-        </p:nvSpPr>
-        <p:spPr>
-          <a:xfrm>
-            <a:off x="4114800" y="3017520"/>
-            <a:ext cx="3200400" cy="228600"/>
-          </a:xfrm>
-          <a:prstGeom prst="rect">
-            <a:avLst/>
-          </a:prstGeom>
-          <a:noFill/>
-          <a:ln/>
-        </p:spPr>
-        <p:txBody>
-          <a:bodyPr wrap="square" rtlCol="0" anchor="ctr"/>
-          <a:lstStyle/>
-          <a:p>
-            <a:pPr algn="ctr" indent="0" marL="0">
-              <a:buNone/>
-            </a:pPr>
-            <a:r>
-              <a:rPr lang="en-US" sz="800" i="1" dirty="0">
-                <a:solidFill>
-                  <a:srgbClr val="666666"/>
-                </a:solidFill>
-                <a:latin typeface="Calibri" pitchFamily="34" charset="0"/>
-                <a:ea typeface="Calibri" pitchFamily="34" charset="-122"/>
-                <a:cs typeface="Calibri" pitchFamily="34" charset="-120"/>
-              </a:rPr>
-              <a:t>trazabilidad bidireccional</a:t>
-            </a:r>
-            <a:endParaRPr lang="en-US" sz="800" dirty="0"/>
-          </a:p>
-        </p:txBody>
-      </p:sp>
-      <p:sp>
-        <p:nvSpPr>
-          <p:cNvPr id="54" name="Shape 52"/>
+          <p:cNvPr id="57" name="Shape 55"/>
           <p:cNvSpPr/>
           <p:nvPr/>
         </p:nvSpPr>
@@ -13527,7 +14050,7 @@
       </p:sp>
       <p:sp>
         <p:nvSpPr>
-          <p:cNvPr id="55" name="Text 53"/>
+          <p:cNvPr id="58" name="Text 56"/>
           <p:cNvSpPr/>
           <p:nvPr/>
         </p:nvSpPr>
@@ -13561,7 +14084,7 @@
                 <a:ea typeface="Calibri" pitchFamily="34" charset="-122"/>
                 <a:cs typeface="Calibri" pitchFamily="34" charset="-120"/>
               </a:rPr>
-              <a:t>La oportunidad nace en Dynamics (1) y se cualifica allí (2). Cuando supera el filtro BANT, se convierte en Demanda dentro del PDB (3), donde el broker ejecuta el seguimiento operativo (4) y abre la negociación (5). El resultado — ganada (6a) o perdida (6b) — se registra de nuevo en Dynamics. La trazabilidad Oportunidad ↔ Demanda ↔ Negociación se mantiene bidireccional en todo momento para reporting y forecasting.</a:t>
+              <a:t>La Oportunidad NO es el origen del ciclo, es WIP intermedio. Nace cuando hay un match Oferta ↔ Demanda (1) con tracción real en el PDB. El broker pulsa Transformar en Oportunidad (2), abriendo Dynamics con datos preasignados (3) para que el usuario complete y cree el registro maestro (4). Dynamics sincroniza la oportunidad de vuelta al PDB en modo lectura (5), donde el broker continúa el seguimiento WIP (6). El estado avanza a Negociación (7a) si hay tracción, o se cierra como Perdida en Dynamics (7b). Es el primer cruce a Dynamics del ciclo comercial.</a:t>
             </a:r>
             <a:endParaRPr lang="en-US" sz="1000" dirty="0"/>
           </a:p>
@@ -15543,7 +16066,7 @@
                 <a:ea typeface="Calibri" pitchFamily="34" charset="-122"/>
                 <a:cs typeface="Calibri" pitchFamily="34" charset="-120"/>
               </a:rPr>
-              <a:t>Cuenta-Arrendatario → alta demanda → matching activos → visitas → shortlist → oferta</a:t>
+              <a:t>Cuenta-Arrendatario → alta demanda → matching contra Ofertas → visitas → shortlist → match definitivo</a:t>
             </a:r>
             <a:endParaRPr lang="en-US" sz="1000" dirty="0"/>
           </a:p>
@@ -16068,7 +16591,7 @@
                 <a:ea typeface="Calibri" pitchFamily="34" charset="-122"/>
                 <a:cs typeface="Calibri" pitchFamily="34" charset="-120"/>
               </a:rPr>
-              <a:t>Uso + sup</a:t>
+              <a:t>uso + sup</a:t>
             </a:r>
             <a:endParaRPr lang="en-US" sz="1000" dirty="0"/>
           </a:p>
@@ -16222,7 +16745,7 @@
                 <a:ea typeface="Calibri" pitchFamily="34" charset="-122"/>
                 <a:cs typeface="Calibri" pitchFamily="34" charset="-120"/>
               </a:rPr>
-              <a:t>Matching Activos</a:t>
+              <a:t>Matching Ofertas</a:t>
             </a:r>
             <a:endParaRPr lang="en-US" sz="1000" dirty="0"/>
           </a:p>
@@ -16240,6 +16763,23 @@
                 <a:cs typeface="Calibri" pitchFamily="34" charset="-120"/>
               </a:rPr>
               <a:t>cruce automático</a:t>
+            </a:r>
+            <a:endParaRPr lang="en-US" sz="1000" dirty="0"/>
+          </a:p>
+          <a:p>
+            <a:pPr algn="ctr" indent="0" marL="0">
+              <a:buNone/>
+            </a:pPr>
+            <a:r>
+              <a:rPr lang="en-US" sz="1000" dirty="0">
+                <a:solidFill>
+                  <a:srgbClr val="FFFFFF"/>
+                </a:solidFill>
+                <a:latin typeface="Calibri" pitchFamily="34" charset="0"/>
+                <a:ea typeface="Calibri" pitchFamily="34" charset="-122"/>
+                <a:cs typeface="Calibri" pitchFamily="34" charset="-120"/>
+              </a:rPr>
+              <a:t>(no contra activos)</a:t>
             </a:r>
             <a:endParaRPr lang="en-US" sz="1000" dirty="0"/>
           </a:p>
@@ -16581,7 +17121,7 @@
                 <a:ea typeface="Calibri" pitchFamily="34" charset="-122"/>
                 <a:cs typeface="Calibri" pitchFamily="34" charset="-120"/>
               </a:rPr>
-              <a:t>3-5</a:t>
+              <a:t>de Ofertas</a:t>
             </a:r>
             <a:endParaRPr lang="en-US" sz="1000" dirty="0"/>
           </a:p>
@@ -16718,7 +17258,7 @@
                 <a:ea typeface="Calibri" pitchFamily="34" charset="-122"/>
                 <a:cs typeface="Calibri" pitchFamily="34" charset="-120"/>
               </a:rPr>
-              <a:t>Oferta</a:t>
+              <a:t>Match</a:t>
             </a:r>
             <a:endParaRPr lang="en-US" sz="1000" dirty="0"/>
           </a:p>
@@ -16735,7 +17275,7 @@
                 <a:ea typeface="Calibri" pitchFamily="34" charset="-122"/>
                 <a:cs typeface="Calibri" pitchFamily="34" charset="-120"/>
               </a:rPr>
-              <a:t>sobre activo</a:t>
+              <a:t>definitivo</a:t>
             </a:r>
             <a:endParaRPr lang="en-US" sz="1000" dirty="0"/>
           </a:p>
@@ -16752,7 +17292,24 @@
                 <a:ea typeface="Calibri" pitchFamily="34" charset="-122"/>
                 <a:cs typeface="Calibri" pitchFamily="34" charset="-120"/>
               </a:rPr>
-              <a:t>final</a:t>
+              <a:t>handoff a</a:t>
+            </a:r>
+            <a:endParaRPr lang="en-US" sz="1000" dirty="0"/>
+          </a:p>
+          <a:p>
+            <a:pPr algn="ctr" indent="0" marL="0">
+              <a:buNone/>
+            </a:pPr>
+            <a:r>
+              <a:rPr lang="en-US" sz="1000" dirty="0">
+                <a:solidFill>
+                  <a:srgbClr val="FFFFFF"/>
+                </a:solidFill>
+                <a:latin typeface="Calibri" pitchFamily="34" charset="0"/>
+                <a:ea typeface="Calibri" pitchFamily="34" charset="-122"/>
+                <a:cs typeface="Calibri" pitchFamily="34" charset="-120"/>
+              </a:rPr>
+              <a:t>Oportunidad</a:t>
             </a:r>
             <a:endParaRPr lang="en-US" sz="1000" dirty="0"/>
           </a:p>
@@ -17046,7 +17603,7 @@
                 <a:ea typeface="Calibri" pitchFamily="34" charset="-122"/>
                 <a:cs typeface="Calibri" pitchFamily="34" charset="-120"/>
               </a:rPr>
-              <a:t>Toda demanda parte de una Cuenta-Arrendatario en Dynamics (1). El broker da de alta la demanda en el PDB (2) con el perfil de búsqueda (uso, superficie, renta máxima, zona). El sistema realiza un matching automático contra los activos disponibles (3), se ejecutan visitas (4) y se construye una shortlist (5) que culmina en una oferta concreta (6) sobre el activo seleccionado.</a:t>
+              <a:t>Toda demanda parte de una Cuenta-Arrendatario en Dynamics (1). El broker da de alta la demanda en el PDB (2) con el perfil de búsqueda. El sistema realiza un matching automático contra las Ofertas publicadas (3) — no contra activos sueltos: el activo está detrás de cada oferta, pero el cruce comercial es Demanda↔Oferta. Se ejecutan visitas (4) y se construye una shortlist de ofertas (5) hasta llegar al match definitivo (6) que dispara el handoff a Oportunidad WIP.</a:t>
             </a:r>
             <a:endParaRPr lang="en-US" sz="1000" dirty="0"/>
           </a:p>
@@ -17245,7 +17802,7 @@
                 <a:ea typeface="Calibri" pitchFamily="34" charset="-122"/>
                 <a:cs typeface="Calibri" pitchFamily="34" charset="-120"/>
               </a:rPr>
-              <a:t>Creación → envío → respuesta → apertura Negociación → versionado documentos → cierre · Vive íntegramente en PDB</a:t>
+              <a:t>Producto al mercado: creación sobre Activo → publicación → match con demanda → handoff a Oportunidad WIP → cierre</a:t>
             </a:r>
             <a:endParaRPr lang="en-US" sz="1000" dirty="0"/>
           </a:p>
@@ -17533,7 +18090,7 @@
                 <a:ea typeface="Calibri" pitchFamily="34" charset="-122"/>
                 <a:cs typeface="Calibri" pitchFamily="34" charset="-120"/>
               </a:rPr>
-              <a:t>Activo + Demanda</a:t>
+              <a:t>cuelga del</a:t>
             </a:r>
             <a:endParaRPr lang="en-US" sz="1000" dirty="0"/>
           </a:p>
@@ -17550,7 +18107,7 @@
                 <a:ea typeface="Calibri" pitchFamily="34" charset="-122"/>
                 <a:cs typeface="Calibri" pitchFamily="34" charset="-120"/>
               </a:rPr>
-              <a:t>+ condiciones</a:t>
+              <a:t>Activo</a:t>
             </a:r>
             <a:endParaRPr lang="en-US" sz="1000" dirty="0"/>
           </a:p>
@@ -17687,7 +18244,7 @@
                 <a:ea typeface="Calibri" pitchFamily="34" charset="-122"/>
                 <a:cs typeface="Calibri" pitchFamily="34" charset="-120"/>
               </a:rPr>
-              <a:t>Envío</a:t>
+              <a:t>Publicación</a:t>
             </a:r>
             <a:endParaRPr lang="en-US" sz="1000" dirty="0"/>
           </a:p>
@@ -17704,7 +18261,24 @@
                 <a:ea typeface="Calibri" pitchFamily="34" charset="-122"/>
                 <a:cs typeface="Calibri" pitchFamily="34" charset="-120"/>
               </a:rPr>
-              <a:t>al propietario</a:t>
+              <a:t>activa al</a:t>
+            </a:r>
+            <a:endParaRPr lang="en-US" sz="1000" dirty="0"/>
+          </a:p>
+          <a:p>
+            <a:pPr algn="ctr" indent="0" marL="0">
+              <a:buNone/>
+            </a:pPr>
+            <a:r>
+              <a:rPr lang="en-US" sz="1000" dirty="0">
+                <a:solidFill>
+                  <a:srgbClr val="FFFFFF"/>
+                </a:solidFill>
+                <a:latin typeface="Calibri" pitchFamily="34" charset="0"/>
+                <a:ea typeface="Calibri" pitchFamily="34" charset="-122"/>
+                <a:cs typeface="Calibri" pitchFamily="34" charset="-120"/>
+              </a:rPr>
+              <a:t>mercado</a:t>
             </a:r>
             <a:endParaRPr lang="en-US" sz="1000" dirty="0"/>
           </a:p>
@@ -17841,7 +18415,7 @@
                 <a:ea typeface="Calibri" pitchFamily="34" charset="-122"/>
                 <a:cs typeface="Calibri" pitchFamily="34" charset="-120"/>
               </a:rPr>
-              <a:t>Respuesta</a:t>
+              <a:t>Recepción</a:t>
             </a:r>
             <a:endParaRPr lang="en-US" sz="1000" dirty="0"/>
           </a:p>
@@ -17858,7 +18432,7 @@
                 <a:ea typeface="Calibri" pitchFamily="34" charset="-122"/>
                 <a:cs typeface="Calibri" pitchFamily="34" charset="-120"/>
               </a:rPr>
-              <a:t>aceptada /</a:t>
+              <a:t>interés</a:t>
             </a:r>
             <a:endParaRPr lang="en-US" sz="1000" dirty="0"/>
           </a:p>
@@ -17875,7 +18449,7 @@
                 <a:ea typeface="Calibri" pitchFamily="34" charset="-122"/>
                 <a:cs typeface="Calibri" pitchFamily="34" charset="-120"/>
               </a:rPr>
-              <a:t>contrapropuesta /</a:t>
+              <a:t>demandas que</a:t>
             </a:r>
             <a:endParaRPr lang="en-US" sz="1000" dirty="0"/>
           </a:p>
@@ -17892,7 +18466,7 @@
                 <a:ea typeface="Calibri" pitchFamily="34" charset="-122"/>
                 <a:cs typeface="Calibri" pitchFamily="34" charset="-120"/>
               </a:rPr>
-              <a:t>rechazada</a:t>
+              <a:t>machean</a:t>
             </a:r>
             <a:endParaRPr lang="en-US" sz="1000" dirty="0"/>
           </a:p>
@@ -18029,7 +18603,7 @@
                 <a:ea typeface="Calibri" pitchFamily="34" charset="-122"/>
                 <a:cs typeface="Calibri" pitchFamily="34" charset="-120"/>
               </a:rPr>
-              <a:t>Apertura</a:t>
+              <a:t>Match</a:t>
             </a:r>
             <a:endParaRPr lang="en-US" sz="1000" dirty="0"/>
           </a:p>
@@ -18046,7 +18620,7 @@
                 <a:ea typeface="Calibri" pitchFamily="34" charset="-122"/>
                 <a:cs typeface="Calibri" pitchFamily="34" charset="-120"/>
               </a:rPr>
-              <a:t>Negociación</a:t>
+              <a:t>con Demanda</a:t>
             </a:r>
             <a:endParaRPr lang="en-US" sz="1000" dirty="0"/>
           </a:p>
@@ -18063,7 +18637,7 @@
                 <a:ea typeface="Calibri" pitchFamily="34" charset="-122"/>
                 <a:cs typeface="Calibri" pitchFamily="34" charset="-120"/>
               </a:rPr>
-              <a:t>hilo formal</a:t>
+              <a:t>concreta</a:t>
             </a:r>
             <a:endParaRPr lang="en-US" sz="1000" dirty="0"/>
           </a:p>
@@ -18200,7 +18774,7 @@
                 <a:ea typeface="Calibri" pitchFamily="34" charset="-122"/>
                 <a:cs typeface="Calibri" pitchFamily="34" charset="-120"/>
               </a:rPr>
-              <a:t>Versionado docs</a:t>
+              <a:t>Handoff</a:t>
             </a:r>
             <a:endParaRPr lang="en-US" sz="1000" dirty="0"/>
           </a:p>
@@ -18217,7 +18791,7 @@
                 <a:ea typeface="Calibri" pitchFamily="34" charset="-122"/>
                 <a:cs typeface="Calibri" pitchFamily="34" charset="-120"/>
               </a:rPr>
-              <a:t>borradores +</a:t>
+              <a:t>Oportunidad</a:t>
             </a:r>
             <a:endParaRPr lang="en-US" sz="1000" dirty="0"/>
           </a:p>
@@ -18234,7 +18808,24 @@
                 <a:ea typeface="Calibri" pitchFamily="34" charset="-122"/>
                 <a:cs typeface="Calibri" pitchFamily="34" charset="-120"/>
               </a:rPr>
-              <a:t>diff</a:t>
+              <a:t>oferta</a:t>
+            </a:r>
+            <a:endParaRPr lang="en-US" sz="1000" dirty="0"/>
+          </a:p>
+          <a:p>
+            <a:pPr algn="ctr" indent="0" marL="0">
+              <a:buNone/>
+            </a:pPr>
+            <a:r>
+              <a:rPr lang="en-US" sz="1000" dirty="0">
+                <a:solidFill>
+                  <a:srgbClr val="FFFFFF"/>
+                </a:solidFill>
+                <a:latin typeface="Calibri" pitchFamily="34" charset="0"/>
+                <a:ea typeface="Calibri" pitchFamily="34" charset="-122"/>
+                <a:cs typeface="Calibri" pitchFamily="34" charset="-120"/>
+              </a:rPr>
+              <a:t>lockeada</a:t>
             </a:r>
             <a:endParaRPr lang="en-US" sz="1000" dirty="0"/>
           </a:p>
@@ -18371,7 +18962,7 @@
                 <a:ea typeface="Calibri" pitchFamily="34" charset="-122"/>
                 <a:cs typeface="Calibri" pitchFamily="34" charset="-120"/>
               </a:rPr>
-              <a:t>Cierre</a:t>
+              <a:t>Cierre Oferta</a:t>
             </a:r>
             <a:endParaRPr lang="en-US" sz="1000" dirty="0"/>
           </a:p>
@@ -18388,7 +18979,7 @@
                 <a:ea typeface="Calibri" pitchFamily="34" charset="-122"/>
                 <a:cs typeface="Calibri" pitchFamily="34" charset="-120"/>
               </a:rPr>
-              <a:t>acuerdo o</a:t>
+              <a:t>retirada del</a:t>
             </a:r>
             <a:endParaRPr lang="en-US" sz="1000" dirty="0"/>
           </a:p>
@@ -18405,7 +18996,7 @@
                 <a:ea typeface="Calibri" pitchFamily="34" charset="-122"/>
                 <a:cs typeface="Calibri" pitchFamily="34" charset="-120"/>
               </a:rPr>
-              <a:t>ruptura</a:t>
+              <a:t>mercado</a:t>
             </a:r>
             <a:endParaRPr lang="en-US" sz="1000" dirty="0"/>
           </a:p>
@@ -18656,7 +19247,7 @@
                 <a:ea typeface="Calibri" pitchFamily="34" charset="-122"/>
                 <a:cs typeface="Calibri" pitchFamily="34" charset="-120"/>
               </a:rPr>
-              <a:t>La oferta vive íntegramente dentro del PDB. Se crea (1) vinculando un activo y una demanda, con las condiciones económicas. Se envía al propietario (2) y se registra su respuesta (3): aceptación, contrapropuesta o rechazo. Si avanza, se abre formalmente la Negociación (4) y se gestiona el versionado de borradores (5) hasta el cierre (6), positivo o negativo. La oferta es siempre el contenedor económico previo a la negociación.</a:t>
+              <a:t>La oferta es el producto disponible al mercado: cuelga del Activo y existe antes de que llegue la demanda concreta que la captura. Se crea (1) sobre el activo con las condiciones publicables, se activa al mercado (2) y empieza a recibir interés de demandas que machean (3). Cuando una demanda concreta selecciona la oferta (4), se ejecuta el handoff a Oportunidad WIP (5) y la oferta queda lockeada — ya no admite nuevas demandas. Tras la transacción o si se retira, la oferta se cierra (6). La oferta es el contenedor de mercado, no el contenedor de la transacción.</a:t>
             </a:r>
             <a:endParaRPr lang="en-US" sz="1000" dirty="0"/>
           </a:p>
@@ -18855,7 +19446,7 @@
                 <a:ea typeface="Calibri" pitchFamily="34" charset="-122"/>
                 <a:cs typeface="Calibri" pitchFamily="34" charset="-120"/>
               </a:rPr>
-              <a:t>Apertura hilo → intercambio condiciones → tabla evolutiva → acuerdo final → handoff a Instrucción</a:t>
+              <a:t>Apertura desde Oportunidad WIP → intercambio condiciones → tabla evolutiva → acuerdo final → handoff #2 a Instrucción</a:t>
             </a:r>
             <a:endParaRPr lang="en-US" sz="1000" dirty="0"/>
           </a:p>
@@ -19209,7 +19800,7 @@
                 <a:ea typeface="Calibri" pitchFamily="34" charset="-122"/>
                 <a:cs typeface="Calibri" pitchFamily="34" charset="-120"/>
               </a:rPr>
-              <a:t>desde Oferta</a:t>
+              <a:t>desde Oportunidad</a:t>
             </a:r>
             <a:endParaRPr lang="en-US" sz="1000" dirty="0"/>
           </a:p>
@@ -19226,7 +19817,7 @@
                 <a:ea typeface="Calibri" pitchFamily="34" charset="-122"/>
                 <a:cs typeface="Calibri" pitchFamily="34" charset="-120"/>
               </a:rPr>
-              <a:t>aceptada</a:t>
+              <a:t>WIP</a:t>
             </a:r>
             <a:endParaRPr lang="en-US" sz="1000" dirty="0"/>
           </a:p>
@@ -19876,7 +20467,7 @@
                 <a:ea typeface="Calibri" pitchFamily="34" charset="-122"/>
                 <a:cs typeface="Calibri" pitchFamily="34" charset="-120"/>
               </a:rPr>
-              <a:t>Handoff a</a:t>
+              <a:t>Handoff #2</a:t>
             </a:r>
             <a:endParaRPr lang="en-US" sz="1000" dirty="0"/>
           </a:p>
@@ -20130,7 +20721,7 @@
                 <a:ea typeface="Calibri" pitchFamily="34" charset="-122"/>
                 <a:cs typeface="Calibri" pitchFamily="34" charset="-120"/>
               </a:rPr>
-              <a:t>handoff</a:t>
+              <a:t>handoff #2</a:t>
             </a:r>
             <a:endParaRPr lang="en-US" sz="800" dirty="0"/>
           </a:p>
@@ -20197,7 +20788,7 @@
                 <a:ea typeface="Calibri" pitchFamily="34" charset="-122"/>
                 <a:cs typeface="Calibri" pitchFamily="34" charset="-120"/>
               </a:rPr>
-              <a:t>La negociación abre un hilo formal a partir de la oferta aceptada como base (1). Las partes intercambian condiciones documentadas en un chat con adjuntos (2), y el PDB mantiene una tabla evolutiva con todas las versiones lado a lado (3) para trazabilidad. Cuando se alcanza el acuerdo final (4), se ejecuta el handoff a Dynamics (5) para crear la Instrucción maestra. No existe contrato sin Instrucción en Dynamics.</a:t>
+              <a:t>La negociación abre un hilo formal a partir de la Oportunidad WIP (1) — no directamente desde la oferta. Las partes intercambian condiciones documentadas en un chat con adjuntos (2), y el PDB mantiene una tabla evolutiva con todas las versiones lado a lado (3) para trazabilidad. Cuando se alcanza el acuerdo final (4), se ejecuta el handoff #2 a Dynamics (5) para crear la Instrucción maestra. No existe contrato sin Instrucción en Dynamics.</a:t>
             </a:r>
             <a:endParaRPr lang="en-US" sz="1000" dirty="0"/>
           </a:p>

</xml_diff>